<commit_message>
V6a deck: wire real UI/CAD screenshots into slides 176/178/180
- 176 DIC HUD  <- DIC HUD UI Screenshot.png
- 178 Settings <- Settings save_UI_Screenshot.png
- 180 Buck enclosure <- Buckconverter_Enclosure_CAD.png (width fitted to 1.16 aspect;
      pin + LED-switch callout arrows land on the render)
Screenshots committed as tracked deck assets.

Co-Authored-By: Claude Opus 4.8 <noreply@anthropic.com>
</commit_message>
<xml_diff>
--- a/documentation/V6a_8_6_20_slides.pptx
+++ b/documentation/V6a_8_6_20_slides.pptx
@@ -44,6 +44,7 @@
     <p:sldId id="292" r:id="rId43"/>
     <p:sldId id="293" r:id="rId44"/>
     <p:sldId id="294" r:id="rId45"/>
+    <p:sldId id="295" r:id="rId46"/>
   </p:sldIdLst>
   <p:sldSz cx="12191695" cy="6858000" type="screen4x3"/>
   <p:notesSz cx="6858000" cy="9144000"/>
@@ -25715,60 +25716,30 @@
           </a:p>
         </p:txBody>
       </p:sp>
-      <p:sp>
-        <p:nvSpPr>
-          <p:cNvPr id="5" name="Rounded Rectangle 4"/>
-          <p:cNvSpPr/>
-          <p:nvPr/>
-        </p:nvSpPr>
-        <p:spPr>
-          <a:xfrm>
-            <a:off x="365760" y="1188720"/>
-            <a:ext cx="7498079" cy="731520"/>
-          </a:xfrm>
-          <a:prstGeom prst="roundRect">
-            <a:avLst/>
-          </a:prstGeom>
-          <a:solidFill>
-            <a:srgbClr val="F2F2F2"/>
-          </a:solidFill>
-          <a:ln w="15240">
-            <a:solidFill>
-              <a:srgbClr val="555555"/>
-            </a:solidFill>
-          </a:ln>
-        </p:spPr>
-        <p:style>
-          <a:lnRef idx="1">
-            <a:schemeClr val="accent1"/>
-          </a:lnRef>
-          <a:fillRef idx="3">
-            <a:schemeClr val="accent1"/>
-          </a:fillRef>
-          <a:effectRef idx="2">
-            <a:schemeClr val="accent1"/>
-          </a:effectRef>
-          <a:fontRef idx="minor">
-            <a:schemeClr val="lt1"/>
-          </a:fontRef>
-        </p:style>
-        <p:txBody>
-          <a:bodyPr rtlCol="0" anchor="ctr" lIns="54864" rIns="54864" tIns="27432" bIns="27432" wrap="square"/>
-          <a:lstStyle/>
-          <a:p>
-            <a:pPr algn="ctr"/>
-            <a:r>
-              <a:rPr sz="1100" b="1">
-                <a:solidFill>
-                  <a:srgbClr val="707070"/>
-                </a:solidFill>
-                <a:latin typeface="Calibri"/>
-              </a:rPr>
-              <a:t>[ drop feat_dic_hud.png here — your DIC-HUD screenshot ]</a:t>
-            </a:r>
-          </a:p>
-        </p:txBody>
-      </p:sp>
+      <p:pic>
+        <p:nvPicPr>
+          <p:cNvPr id="5" name="Picture 4" descr="DIC HUD UI Screenshot.png"/>
+          <p:cNvPicPr>
+            <a:picLocks noChangeAspect="1"/>
+          </p:cNvPicPr>
+          <p:nvPr/>
+        </p:nvPicPr>
+        <p:blipFill>
+          <a:blip r:embed="rId2"/>
+          <a:stretch>
+            <a:fillRect/>
+          </a:stretch>
+        </p:blipFill>
+        <p:spPr>
+          <a:xfrm>
+            <a:off x="365760" y="1234440"/>
+            <a:ext cx="7498079" cy="823488"/>
+          </a:xfrm>
+          <a:prstGeom prst="rect">
+            <a:avLst/>
+          </a:prstGeom>
+        </p:spPr>
+      </p:pic>
       <p:sp>
         <p:nvSpPr>
           <p:cNvPr id="6" name="TextBox 5"/>
@@ -27006,60 +26977,30 @@
           </a:p>
         </p:txBody>
       </p:sp>
-      <p:sp>
-        <p:nvSpPr>
-          <p:cNvPr id="8" name="Rounded Rectangle 7"/>
-          <p:cNvSpPr/>
-          <p:nvPr/>
-        </p:nvSpPr>
-        <p:spPr>
-          <a:xfrm>
-            <a:off x="6355080" y="1627632"/>
-            <a:ext cx="5486400" cy="548640"/>
-          </a:xfrm>
-          <a:prstGeom prst="roundRect">
-            <a:avLst/>
-          </a:prstGeom>
-          <a:solidFill>
-            <a:srgbClr val="F2F2F2"/>
-          </a:solidFill>
-          <a:ln w="15240">
-            <a:solidFill>
-              <a:srgbClr val="555555"/>
-            </a:solidFill>
-          </a:ln>
-        </p:spPr>
-        <p:style>
-          <a:lnRef idx="1">
-            <a:schemeClr val="accent1"/>
-          </a:lnRef>
-          <a:fillRef idx="3">
-            <a:schemeClr val="accent1"/>
-          </a:fillRef>
-          <a:effectRef idx="2">
-            <a:schemeClr val="accent1"/>
-          </a:effectRef>
-          <a:fontRef idx="minor">
-            <a:schemeClr val="lt1"/>
-          </a:fontRef>
-        </p:style>
-        <p:txBody>
-          <a:bodyPr rtlCol="0" anchor="ctr" lIns="54864" rIns="54864" tIns="27432" bIns="27432" wrap="square"/>
-          <a:lstStyle/>
-          <a:p>
-            <a:pPr algn="ctr"/>
-            <a:r>
-              <a:rPr sz="1100" b="1">
-                <a:solidFill>
-                  <a:srgbClr val="707070"/>
-                </a:solidFill>
-                <a:latin typeface="Calibri"/>
-              </a:rPr>
-              <a:t>[ drop feat_settings_ui.png here — your Settings screenshot ]</a:t>
-            </a:r>
-          </a:p>
-        </p:txBody>
-      </p:sp>
+      <p:pic>
+        <p:nvPicPr>
+          <p:cNvPr id="8" name="Picture 7" descr="Settings save_UI_Screenshot.png"/>
+          <p:cNvPicPr>
+            <a:picLocks noChangeAspect="1"/>
+          </p:cNvPicPr>
+          <p:nvPr/>
+        </p:nvPicPr>
+        <p:blipFill>
+          <a:blip r:embed="rId3"/>
+          <a:stretch>
+            <a:fillRect/>
+          </a:stretch>
+        </p:blipFill>
+        <p:spPr>
+          <a:xfrm>
+            <a:off x="6355080" y="1691640"/>
+            <a:ext cx="5486400" cy="216487"/>
+          </a:xfrm>
+          <a:prstGeom prst="rect">
+            <a:avLst/>
+          </a:prstGeom>
+        </p:spPr>
+      </p:pic>
       <p:sp>
         <p:nvSpPr>
           <p:cNvPr id="9" name="TextBox 8"/>
@@ -29317,6 +29258,518 @@
                 <a:latin typeface="Calibri"/>
               </a:rPr>
               <a:t>144</a:t>
+            </a:r>
+          </a:p>
+        </p:txBody>
+      </p:sp>
+    </p:spTree>
+  </p:cSld>
+  <p:clrMapOvr>
+    <a:masterClrMapping/>
+  </p:clrMapOvr>
+</p:sld>
+</file>
+
+<file path=ppt/slides/slide40.xml><?xml version="1.0" encoding="utf-8"?>
+<p:sld xmlns:a="http://schemas.openxmlformats.org/drawingml/2006/main" xmlns:p="http://schemas.openxmlformats.org/presentationml/2006/main" xmlns:r="http://schemas.openxmlformats.org/officeDocument/2006/relationships">
+  <p:cSld>
+    <p:spTree>
+      <p:nvGrpSpPr>
+        <p:cNvPr id="1" name=""/>
+        <p:cNvGrpSpPr/>
+        <p:nvPr/>
+      </p:nvGrpSpPr>
+      <p:grpSpPr/>
+      <p:sp>
+        <p:nvSpPr>
+          <p:cNvPr id="2" name="TextBox 1"/>
+          <p:cNvSpPr txBox="1"/>
+          <p:nvPr/>
+        </p:nvSpPr>
+        <p:spPr>
+          <a:xfrm>
+            <a:off x="11155680" y="274320"/>
+            <a:ext cx="914400" cy="274320"/>
+          </a:xfrm>
+          <a:prstGeom prst="rect">
+            <a:avLst/>
+          </a:prstGeom>
+          <a:noFill/>
+        </p:spPr>
+        <p:txBody>
+          <a:bodyPr wrap="square" lIns="45720" rIns="45720" tIns="18288" bIns="18288" anchor="t">
+            <a:spAutoFit/>
+          </a:bodyPr>
+          <a:lstStyle/>
+          <a:p>
+            <a:pPr algn="r"/>
+            <a:r>
+              <a:rPr sz="800" b="1" i="0">
+                <a:solidFill>
+                  <a:srgbClr val="707070"/>
+                </a:solidFill>
+                <a:latin typeface="Calibri"/>
+              </a:rPr>
+              <a:t>JÖNKÖPING UNIVERSITY</a:t>
+            </a:r>
+          </a:p>
+        </p:txBody>
+      </p:sp>
+      <p:sp>
+        <p:nvSpPr>
+          <p:cNvPr id="3" name="Rectangle 2"/>
+          <p:cNvSpPr/>
+          <p:nvPr/>
+        </p:nvSpPr>
+        <p:spPr>
+          <a:xfrm>
+            <a:off x="457200" y="411480"/>
+            <a:ext cx="457200" cy="73152"/>
+          </a:xfrm>
+          <a:prstGeom prst="rect">
+            <a:avLst/>
+          </a:prstGeom>
+          <a:solidFill>
+            <a:srgbClr val="A9D6EF"/>
+          </a:solidFill>
+          <a:ln>
+            <a:noFill/>
+          </a:ln>
+        </p:spPr>
+        <p:style>
+          <a:lnRef idx="1">
+            <a:schemeClr val="accent1"/>
+          </a:lnRef>
+          <a:fillRef idx="3">
+            <a:schemeClr val="accent1"/>
+          </a:fillRef>
+          <a:effectRef idx="2">
+            <a:schemeClr val="accent1"/>
+          </a:effectRef>
+          <a:fontRef idx="minor">
+            <a:schemeClr val="lt1"/>
+          </a:fontRef>
+        </p:style>
+        <p:txBody>
+          <a:bodyPr rtlCol="0" anchor="ctr"/>
+          <a:lstStyle/>
+          <a:p>
+            <a:pPr algn="ctr"/>
+          </a:p>
+        </p:txBody>
+      </p:sp>
+      <p:sp>
+        <p:nvSpPr>
+          <p:cNvPr id="4" name="TextBox 3"/>
+          <p:cNvSpPr txBox="1"/>
+          <p:nvPr/>
+        </p:nvSpPr>
+        <p:spPr>
+          <a:xfrm>
+            <a:off x="457200" y="502920"/>
+            <a:ext cx="11430000" cy="822960"/>
+          </a:xfrm>
+          <a:prstGeom prst="rect">
+            <a:avLst/>
+          </a:prstGeom>
+          <a:noFill/>
+        </p:spPr>
+        <p:txBody>
+          <a:bodyPr wrap="square" lIns="45720" rIns="45720" tIns="18288" bIns="18288" anchor="t">
+            <a:spAutoFit/>
+          </a:bodyPr>
+          <a:lstStyle/>
+          <a:p>
+            <a:pPr algn="l"/>
+            <a:r>
+              <a:rPr sz="3000" b="0" i="0">
+                <a:solidFill>
+                  <a:srgbClr val="000000"/>
+                </a:solidFill>
+                <a:latin typeface="Calibri Light"/>
+              </a:rPr>
+              <a:t>BUCK-CONVERTER ENCLOSURE — CAD (PLA)</a:t>
+            </a:r>
+          </a:p>
+        </p:txBody>
+      </p:sp>
+      <p:pic>
+        <p:nvPicPr>
+          <p:cNvPr id="5" name="Picture 4" descr="Buckconverter_Enclosure_CAD.png"/>
+          <p:cNvPicPr>
+            <a:picLocks noChangeAspect="1"/>
+          </p:cNvPicPr>
+          <p:nvPr/>
+        </p:nvPicPr>
+        <p:blipFill>
+          <a:blip r:embed="rId2"/>
+          <a:stretch>
+            <a:fillRect/>
+          </a:stretch>
+        </p:blipFill>
+        <p:spPr>
+          <a:xfrm>
+            <a:off x="457200" y="1280160"/>
+            <a:ext cx="5760720" cy="4966587"/>
+          </a:xfrm>
+          <a:prstGeom prst="rect">
+            <a:avLst/>
+          </a:prstGeom>
+        </p:spPr>
+      </p:pic>
+      <p:sp>
+        <p:nvSpPr>
+          <p:cNvPr id="6" name="TextBox 5"/>
+          <p:cNvSpPr txBox="1"/>
+          <p:nvPr/>
+        </p:nvSpPr>
+        <p:spPr>
+          <a:xfrm>
+            <a:off x="6720840" y="1170432"/>
+            <a:ext cx="5074920" cy="365760"/>
+          </a:xfrm>
+          <a:prstGeom prst="rect">
+            <a:avLst/>
+          </a:prstGeom>
+          <a:noFill/>
+        </p:spPr>
+        <p:txBody>
+          <a:bodyPr wrap="square" lIns="45720" rIns="45720" tIns="18288" bIns="18288" anchor="t">
+            <a:spAutoFit/>
+          </a:bodyPr>
+          <a:lstStyle/>
+          <a:p>
+            <a:pPr algn="l"/>
+            <a:r>
+              <a:rPr sz="1600" b="0" i="0">
+                <a:solidFill>
+                  <a:srgbClr val="707070"/>
+                </a:solidFill>
+                <a:latin typeface="Calibri"/>
+              </a:rPr>
+              <a:t>Purpose</a:t>
+            </a:r>
+          </a:p>
+        </p:txBody>
+      </p:sp>
+      <p:sp>
+        <p:nvSpPr>
+          <p:cNvPr id="7" name="TextBox 6"/>
+          <p:cNvSpPr txBox="1"/>
+          <p:nvPr/>
+        </p:nvSpPr>
+        <p:spPr>
+          <a:xfrm>
+            <a:off x="6720840" y="1554480"/>
+            <a:ext cx="5074920" cy="868680"/>
+          </a:xfrm>
+          <a:prstGeom prst="rect">
+            <a:avLst/>
+          </a:prstGeom>
+          <a:noFill/>
+        </p:spPr>
+        <p:txBody>
+          <a:bodyPr wrap="square" lIns="45720" rIns="45720" tIns="18288" bIns="18288" anchor="t">
+            <a:spAutoFit/>
+          </a:bodyPr>
+          <a:lstStyle/>
+          <a:p>
+            <a:pPr algn="l"/>
+            <a:r>
+              <a:rPr sz="1200" b="0" i="0">
+                <a:solidFill>
+                  <a:srgbClr val="000000"/>
+                </a:solidFill>
+                <a:latin typeface="Calibri"/>
+              </a:rPr>
+              <a:t>PLA-printed enclosure that houses the buck converter powering the LED ring lights.</a:t>
+            </a:r>
+          </a:p>
+        </p:txBody>
+      </p:sp>
+      <p:sp>
+        <p:nvSpPr>
+          <p:cNvPr id="8" name="Rounded Rectangle 7"/>
+          <p:cNvSpPr/>
+          <p:nvPr/>
+        </p:nvSpPr>
+        <p:spPr>
+          <a:xfrm>
+            <a:off x="6720840" y="2542032"/>
+            <a:ext cx="3246120" cy="566928"/>
+          </a:xfrm>
+          <a:prstGeom prst="roundRect">
+            <a:avLst/>
+          </a:prstGeom>
+          <a:solidFill>
+            <a:srgbClr val="E7F1F8"/>
+          </a:solidFill>
+          <a:ln w="15240">
+            <a:solidFill>
+              <a:srgbClr val="D62728"/>
+            </a:solidFill>
+          </a:ln>
+        </p:spPr>
+        <p:style>
+          <a:lnRef idx="1">
+            <a:schemeClr val="accent1"/>
+          </a:lnRef>
+          <a:fillRef idx="3">
+            <a:schemeClr val="accent1"/>
+          </a:fillRef>
+          <a:effectRef idx="2">
+            <a:schemeClr val="accent1"/>
+          </a:effectRef>
+          <a:fontRef idx="minor">
+            <a:schemeClr val="lt1"/>
+          </a:fontRef>
+        </p:style>
+        <p:txBody>
+          <a:bodyPr rtlCol="0" anchor="ctr" lIns="54864" rIns="54864" tIns="27432" bIns="27432" wrap="square"/>
+          <a:lstStyle/>
+          <a:p>
+            <a:pPr algn="ctr"/>
+            <a:r>
+              <a:rPr sz="1200" b="1">
+                <a:solidFill>
+                  <a:srgbClr val="000000"/>
+                </a:solidFill>
+                <a:latin typeface="Calibri"/>
+              </a:rPr>
+              <a:t>1 · PCB locating pins</a:t>
+            </a:r>
+          </a:p>
+        </p:txBody>
+      </p:sp>
+      <p:cxnSp>
+        <p:nvCxnSpPr>
+          <p:cNvPr id="9" name="Connector 8"/>
+          <p:cNvCxnSpPr/>
+          <p:nvPr/>
+        </p:nvCxnSpPr>
+        <p:spPr>
+          <a:xfrm flipH="1">
+            <a:off x="3840480" y="2825496"/>
+            <a:ext cx="2880360" cy="100584"/>
+          </a:xfrm>
+          <a:prstGeom prst="line">
+            <a:avLst/>
+          </a:prstGeom>
+          <a:ln w="28575">
+            <a:solidFill>
+              <a:srgbClr val="D62728"/>
+            </a:solidFill>
+            <a:tailEnd type="triangle" w="med" len="med"/>
+          </a:ln>
+        </p:spPr>
+        <p:style>
+          <a:lnRef idx="2">
+            <a:schemeClr val="accent1"/>
+          </a:lnRef>
+          <a:fillRef idx="0">
+            <a:schemeClr val="accent1"/>
+          </a:fillRef>
+          <a:effectRef idx="1">
+            <a:schemeClr val="accent1"/>
+          </a:effectRef>
+          <a:fontRef idx="minor">
+            <a:schemeClr val="tx1"/>
+          </a:fontRef>
+        </p:style>
+      </p:cxnSp>
+      <p:sp>
+        <p:nvSpPr>
+          <p:cNvPr id="10" name="Rounded Rectangle 9"/>
+          <p:cNvSpPr/>
+          <p:nvPr/>
+        </p:nvSpPr>
+        <p:spPr>
+          <a:xfrm>
+            <a:off x="6720840" y="3977639"/>
+            <a:ext cx="3611880" cy="566928"/>
+          </a:xfrm>
+          <a:prstGeom prst="roundRect">
+            <a:avLst/>
+          </a:prstGeom>
+          <a:solidFill>
+            <a:srgbClr val="E7F1F8"/>
+          </a:solidFill>
+          <a:ln w="15240">
+            <a:solidFill>
+              <a:srgbClr val="D62728"/>
+            </a:solidFill>
+          </a:ln>
+        </p:spPr>
+        <p:style>
+          <a:lnRef idx="1">
+            <a:schemeClr val="accent1"/>
+          </a:lnRef>
+          <a:fillRef idx="3">
+            <a:schemeClr val="accent1"/>
+          </a:fillRef>
+          <a:effectRef idx="2">
+            <a:schemeClr val="accent1"/>
+          </a:effectRef>
+          <a:fontRef idx="minor">
+            <a:schemeClr val="lt1"/>
+          </a:fontRef>
+        </p:style>
+        <p:txBody>
+          <a:bodyPr rtlCol="0" anchor="ctr" lIns="54864" rIns="54864" tIns="27432" bIns="27432" wrap="square"/>
+          <a:lstStyle/>
+          <a:p>
+            <a:pPr algn="ctr"/>
+            <a:r>
+              <a:rPr sz="1200" b="1">
+                <a:solidFill>
+                  <a:srgbClr val="000000"/>
+                </a:solidFill>
+                <a:latin typeface="Calibri"/>
+              </a:rPr>
+              <a:t>2 · LED-switch extrusion</a:t>
+            </a:r>
+          </a:p>
+        </p:txBody>
+      </p:sp>
+      <p:cxnSp>
+        <p:nvCxnSpPr>
+          <p:cNvPr id="11" name="Connector 10"/>
+          <p:cNvCxnSpPr/>
+          <p:nvPr/>
+        </p:nvCxnSpPr>
+        <p:spPr>
+          <a:xfrm flipH="1">
+            <a:off x="1828800" y="4261104"/>
+            <a:ext cx="4892040" cy="356616"/>
+          </a:xfrm>
+          <a:prstGeom prst="line">
+            <a:avLst/>
+          </a:prstGeom>
+          <a:ln w="28575">
+            <a:solidFill>
+              <a:srgbClr val="D62728"/>
+            </a:solidFill>
+            <a:tailEnd type="triangle" w="med" len="med"/>
+          </a:ln>
+        </p:spPr>
+        <p:style>
+          <a:lnRef idx="2">
+            <a:schemeClr val="accent1"/>
+          </a:lnRef>
+          <a:fillRef idx="0">
+            <a:schemeClr val="accent1"/>
+          </a:fillRef>
+          <a:effectRef idx="1">
+            <a:schemeClr val="accent1"/>
+          </a:effectRef>
+          <a:fontRef idx="minor">
+            <a:schemeClr val="tx1"/>
+          </a:fontRef>
+        </p:style>
+      </p:cxnSp>
+      <p:sp>
+        <p:nvSpPr>
+          <p:cNvPr id="12" name="TextBox 11"/>
+          <p:cNvSpPr txBox="1"/>
+          <p:nvPr/>
+        </p:nvSpPr>
+        <p:spPr>
+          <a:xfrm>
+            <a:off x="6720840" y="4828032"/>
+            <a:ext cx="5074920" cy="1280160"/>
+          </a:xfrm>
+          <a:prstGeom prst="rect">
+            <a:avLst/>
+          </a:prstGeom>
+          <a:noFill/>
+        </p:spPr>
+        <p:txBody>
+          <a:bodyPr wrap="square" lIns="45720" rIns="45720" tIns="18288" bIns="18288" anchor="t">
+            <a:spAutoFit/>
+          </a:bodyPr>
+          <a:lstStyle/>
+          <a:p>
+            <a:pPr algn="l"/>
+            <a:r>
+              <a:rPr sz="1150" b="0" i="0">
+                <a:solidFill>
+                  <a:srgbClr val="000000"/>
+                </a:solidFill>
+                <a:latin typeface="Calibri"/>
+              </a:rPr>
+              <a:t>•  Pins align + hold the buck-converter PCB
+•  Side extrusion = housing for the LED on/off switch
+•  Open top + side slots for wiring / mounting</a:t>
+            </a:r>
+          </a:p>
+        </p:txBody>
+      </p:sp>
+      <p:sp>
+        <p:nvSpPr>
+          <p:cNvPr id="13" name="TextBox 12"/>
+          <p:cNvSpPr txBox="1"/>
+          <p:nvPr/>
+        </p:nvSpPr>
+        <p:spPr>
+          <a:xfrm>
+            <a:off x="548640" y="6400800"/>
+            <a:ext cx="11064240" cy="365760"/>
+          </a:xfrm>
+          <a:prstGeom prst="rect">
+            <a:avLst/>
+          </a:prstGeom>
+          <a:noFill/>
+        </p:spPr>
+        <p:txBody>
+          <a:bodyPr wrap="square" lIns="45720" rIns="45720" tIns="18288" bIns="18288" anchor="t">
+            <a:spAutoFit/>
+          </a:bodyPr>
+          <a:lstStyle/>
+          <a:p>
+            <a:pPr algn="l"/>
+            <a:r>
+              <a:rPr sz="1200" b="0" i="1">
+                <a:solidFill>
+                  <a:srgbClr val="707070"/>
+                </a:solidFill>
+                <a:latin typeface="Calibri"/>
+              </a:rPr>
+              <a:t>CAD for a PLA-printed part. Callout arrows mark the PCB locating pins (floor posts) and the LED-switch extrusion (side tube).</a:t>
+            </a:r>
+          </a:p>
+        </p:txBody>
+      </p:sp>
+      <p:sp>
+        <p:nvSpPr>
+          <p:cNvPr id="14" name="TextBox 13"/>
+          <p:cNvSpPr txBox="1"/>
+          <p:nvPr/>
+        </p:nvSpPr>
+        <p:spPr>
+          <a:xfrm>
+            <a:off x="457200" y="6446520"/>
+            <a:ext cx="640080" cy="274320"/>
+          </a:xfrm>
+          <a:prstGeom prst="rect">
+            <a:avLst/>
+          </a:prstGeom>
+          <a:noFill/>
+        </p:spPr>
+        <p:txBody>
+          <a:bodyPr wrap="square" lIns="45720" rIns="45720" tIns="18288" bIns="18288" anchor="t">
+            <a:spAutoFit/>
+          </a:bodyPr>
+          <a:lstStyle/>
+          <a:p>
+            <a:pPr algn="l"/>
+            <a:r>
+              <a:rPr sz="1000" b="0" i="0">
+                <a:solidFill>
+                  <a:srgbClr val="707070"/>
+                </a:solidFill>
+                <a:latin typeface="Calibri"/>
+              </a:rPr>
+              <a:t>180</a:t>
             </a:r>
           </a:p>
         </p:txBody>

</xml_diff>

<commit_message>
V6a deck (slide 163): replace text wall with a necking-specimen schematic (A0 -> A)
Less text, more physical representation: a diagram of a specimen necking under load
(original area A0 shrinking to A at the neck, F pull arrows) + two compact lines
instead of the paragraph. New asset feat_eng_vs_true.png.

Co-Authored-By: Claude Opus 4.8 <noreply@anthropic.com>
</commit_message>
<xml_diff>
--- a/documentation/V6a_8_6_20_slides.pptx
+++ b/documentation/V6a_8_6_20_slides.pptx
@@ -16141,21 +16141,45 @@
                 </a:solidFill>
                 <a:latin typeface="Calibri"/>
               </a:rPr>
-              <a:t>Why the report &amp; plots use ENGINEERING stress</a:t>
-            </a:r>
-          </a:p>
-        </p:txBody>
-      </p:sp>
-      <p:sp>
-        <p:nvSpPr>
-          <p:cNvPr id="6" name="TextBox 5"/>
+              <a:t>Why we REPORT engineering stress</a:t>
+            </a:r>
+          </a:p>
+        </p:txBody>
+      </p:sp>
+      <p:pic>
+        <p:nvPicPr>
+          <p:cNvPr id="6" name="Picture 5" descr="feat_eng_vs_true.png"/>
+          <p:cNvPicPr>
+            <a:picLocks noChangeAspect="1"/>
+          </p:cNvPicPr>
+          <p:nvPr/>
+        </p:nvPicPr>
+        <p:blipFill>
+          <a:blip r:embed="rId2"/>
+          <a:stretch>
+            <a:fillRect/>
+          </a:stretch>
+        </p:blipFill>
+        <p:spPr>
+          <a:xfrm>
+            <a:off x="365760" y="1517904"/>
+            <a:ext cx="5623560" cy="2309892"/>
+          </a:xfrm>
+          <a:prstGeom prst="rect">
+            <a:avLst/>
+          </a:prstGeom>
+        </p:spPr>
+      </p:pic>
+      <p:sp>
+        <p:nvSpPr>
+          <p:cNvPr id="7" name="TextBox 6"/>
           <p:cNvSpPr txBox="1"/>
           <p:nvPr/>
         </p:nvSpPr>
         <p:spPr>
           <a:xfrm>
-            <a:off x="365760" y="1554480"/>
-            <a:ext cx="5623560" cy="3383280"/>
+            <a:off x="365760" y="3950208"/>
+            <a:ext cx="5623560" cy="1051560"/>
           </a:xfrm>
           <a:prstGeom prst="rect">
             <a:avLst/>
@@ -16170,24 +16194,21 @@
           <a:p>
             <a:pPr algn="l"/>
             <a:r>
-              <a:rPr sz="1150" b="0" i="0">
+              <a:rPr sz="1100" b="0" i="0">
                 <a:solidFill>
                   <a:srgbClr val="000000"/>
                 </a:solidFill>
                 <a:latin typeface="Calibri"/>
               </a:rPr>
-              <a:t>σ_eng = F / A₀   (A₀ = 80 mm², fixed) — what we compute &amp; report.
-σ_true (Cauchy) = F / A_current — the real stress on the shrinking cross-section; NOT measured here (the deforming area is never tracked).
-Link (uniform, pre-neck):   σ_true = σ_eng·(1+ε),    ε_true = ln(1+ε).
-WHY engineering: ISO 527, Chacón (2017) and the add:north datasheet all report ENGINEERING stress — so it is the apples-to-apples basis for our k-factors / PASS–FAIL. True stress reads higher and would break that comparison.
-Gap for our PLA (small strains): ~2–3 % higher at UTS (46.2 → ~47 MPa), ~5 % near fracture; E and σ_y essentially unchanged.</a:t>
-            </a:r>
-          </a:p>
-        </p:txBody>
-      </p:sp>
-      <p:sp>
-        <p:nvSpPr>
-          <p:cNvPr id="7" name="TextBox 6"/>
+              <a:t>σ_eng = F / A₀  (REPORTED)      σ_true = F / A  (not tracked, ~2–5% higher)
+Basis: ISO 527 · Chacón · datasheet all use ENGINEERING → apples-to-apples for our k-factors.  E &amp; σ_y ~unchanged.</a:t>
+            </a:r>
+          </a:p>
+        </p:txBody>
+      </p:sp>
+      <p:sp>
+        <p:nvSpPr>
+          <p:cNvPr id="8" name="TextBox 7"/>
           <p:cNvSpPr txBox="1"/>
           <p:nvPr/>
         </p:nvSpPr>
@@ -16222,7 +16243,7 @@
       </p:sp>
       <p:graphicFrame>
         <p:nvGraphicFramePr>
-          <p:cNvPr id="8" name="Table 7"/>
+          <p:cNvPr id="9" name="Table 8"/>
           <p:cNvGraphicFramePr>
             <a:graphicFrameLocks noGrp="1"/>
           </p:cNvGraphicFramePr>
@@ -16568,7 +16589,7 @@
       </p:graphicFrame>
       <p:sp>
         <p:nvSpPr>
-          <p:cNvPr id="9" name="TextBox 8"/>
+          <p:cNvPr id="10" name="TextBox 9"/>
           <p:cNvSpPr txBox="1"/>
           <p:nvPr/>
         </p:nvSpPr>
@@ -16603,7 +16624,7 @@
       </p:sp>
       <p:sp>
         <p:nvSpPr>
-          <p:cNvPr id="10" name="Rectangle 9"/>
+          <p:cNvPr id="11" name="Rectangle 10"/>
           <p:cNvSpPr/>
           <p:nvPr/>
         </p:nvSpPr>
@@ -16655,7 +16676,7 @@
       </p:sp>
       <p:sp>
         <p:nvSpPr>
-          <p:cNvPr id="11" name="TextBox 10"/>
+          <p:cNvPr id="12" name="TextBox 11"/>
           <p:cNvSpPr txBox="1"/>
           <p:nvPr/>
         </p:nvSpPr>
@@ -16690,7 +16711,7 @@
       </p:sp>
       <p:sp>
         <p:nvSpPr>
-          <p:cNvPr id="12" name="TextBox 11"/>
+          <p:cNvPr id="13" name="TextBox 12"/>
           <p:cNvSpPr txBox="1"/>
           <p:nvPr/>
         </p:nvSpPr>

</xml_diff>

<commit_message>
V6a deck: +2 hardware slides — motor torque ceiling + jitter/stall warning
- Motor torque ceiling (181): variable ~2.6 kN weak-day vs 3.2-3.8 kN strong-day at
  the SAME speed; 100% full-area needs ~3.7 kN. Why (Vref / thermal / PSU / binding,
  NOT speed). Workaround = 50%/smaller specimens.
- Motor jitter = stall warning (182): S17 stall+jitter plot (force stuck ~2.9 kN,
  speed oscillating), why it happens, and the WARNING (jitter=stall, stop; stall
  guard now auto-halts). New asset feat_motor_jitter.png.
Renumbered to 45 slides (141-185).

Co-Authored-By: Claude Opus 4.8 <noreply@anthropic.com>
</commit_message>
<xml_diff>
--- a/documentation/V6a_8_6_20_slides.pptx
+++ b/documentation/V6a_8_6_20_slides.pptx
@@ -48,6 +48,8 @@
     <p:sldId id="296" r:id="rId47"/>
     <p:sldId id="297" r:id="rId48"/>
     <p:sldId id="298" r:id="rId49"/>
+    <p:sldId id="299" r:id="rId50"/>
+    <p:sldId id="300" r:id="rId51"/>
   </p:sldIdLst>
   <p:sldSz cx="12191695" cy="6858000" type="screen4x3"/>
   <p:notesSz cx="6858000" cy="9144000"/>
@@ -29949,7 +29951,7 @@
                 </a:solidFill>
                 <a:latin typeface="Calibri Light"/>
               </a:rPr>
-              <a:t>MEASURING CAUCHY (TRUE) STRESS</a:t>
+              <a:t>MOTOR TORQUE CEILING — THE 100% FRACTURE LIMIT</a:t>
             </a:r>
           </a:p>
         </p:txBody>
@@ -29962,8 +29964,8 @@
         </p:nvSpPr>
         <p:spPr>
           <a:xfrm>
-            <a:off x="365760" y="2651760"/>
-            <a:ext cx="11475720" cy="1554480"/>
+            <a:off x="365760" y="1170432"/>
+            <a:ext cx="11475720" cy="365760"/>
           </a:xfrm>
           <a:prstGeom prst="rect">
             <a:avLst/>
@@ -29978,20 +29980,406 @@
           <a:p>
             <a:pPr algn="l"/>
             <a:r>
-              <a:rPr sz="1600" b="1" i="0">
+              <a:rPr sz="1600" b="0" i="0">
+                <a:solidFill>
+                  <a:srgbClr val="707070"/>
+                </a:solidFill>
+                <a:latin typeface="Calibri"/>
+              </a:rPr>
+              <a:t>Same crosshead speed (0.10 mm/s), different MAX force</a:t>
+            </a:r>
+          </a:p>
+        </p:txBody>
+      </p:sp>
+      <p:sp>
+        <p:nvSpPr>
+          <p:cNvPr id="6" name="Rounded Rectangle 5"/>
+          <p:cNvSpPr/>
+          <p:nvPr/>
+        </p:nvSpPr>
+        <p:spPr>
+          <a:xfrm>
+            <a:off x="365760" y="1600200"/>
+            <a:ext cx="3657600" cy="896112"/>
+          </a:xfrm>
+          <a:prstGeom prst="roundRect">
+            <a:avLst/>
+          </a:prstGeom>
+          <a:solidFill>
+            <a:srgbClr val="E7F1F8"/>
+          </a:solidFill>
+          <a:ln>
+            <a:noFill/>
+          </a:ln>
+        </p:spPr>
+        <p:style>
+          <a:lnRef idx="1">
+            <a:schemeClr val="accent1"/>
+          </a:lnRef>
+          <a:fillRef idx="3">
+            <a:schemeClr val="accent1"/>
+          </a:fillRef>
+          <a:effectRef idx="2">
+            <a:schemeClr val="accent1"/>
+          </a:effectRef>
+          <a:fontRef idx="minor">
+            <a:schemeClr val="lt1"/>
+          </a:fontRef>
+        </p:style>
+        <p:txBody>
+          <a:bodyPr rtlCol="0" anchor="ctr" lIns="54864" rIns="54864" bIns="27432" wrap="square"/>
+          <a:lstStyle/>
+          <a:p>
+            <a:pPr algn="ctr"/>
+            <a:r>
+              <a:rPr sz="1800" b="1">
                 <a:solidFill>
                   <a:srgbClr val="1F3F2F"/>
                 </a:solidFill>
                 <a:latin typeface="Calibri"/>
               </a:rPr>
-              <a:t>Getting the DEFORMING cross-section for TRUE / Cauchy stress + Poisson ratio - a separate future work-stream: edge-width tracking on a matte-black backdrop.</a:t>
-            </a:r>
-          </a:p>
-        </p:txBody>
-      </p:sp>
-      <p:sp>
-        <p:nvSpPr>
-          <p:cNvPr id="6" name="TextBox 5"/>
+              <a:t>~2.6 kN</a:t>
+            </a:r>
+          </a:p>
+          <a:p>
+            <a:pPr algn="ctr"/>
+            <a:r>
+              <a:rPr sz="950">
+                <a:solidFill>
+                  <a:srgbClr val="000000"/>
+                </a:solidFill>
+                <a:latin typeface="Calibri"/>
+              </a:rPr>
+              <a:t>WEAK DAY (S15 · today)</a:t>
+            </a:r>
+          </a:p>
+        </p:txBody>
+      </p:sp>
+      <p:sp>
+        <p:nvSpPr>
+          <p:cNvPr id="7" name="Rounded Rectangle 6"/>
+          <p:cNvSpPr/>
+          <p:nvPr/>
+        </p:nvSpPr>
+        <p:spPr>
+          <a:xfrm>
+            <a:off x="4206240" y="1600200"/>
+            <a:ext cx="3657600" cy="896112"/>
+          </a:xfrm>
+          <a:prstGeom prst="roundRect">
+            <a:avLst/>
+          </a:prstGeom>
+          <a:solidFill>
+            <a:srgbClr val="E7F1F8"/>
+          </a:solidFill>
+          <a:ln>
+            <a:noFill/>
+          </a:ln>
+        </p:spPr>
+        <p:style>
+          <a:lnRef idx="1">
+            <a:schemeClr val="accent1"/>
+          </a:lnRef>
+          <a:fillRef idx="3">
+            <a:schemeClr val="accent1"/>
+          </a:fillRef>
+          <a:effectRef idx="2">
+            <a:schemeClr val="accent1"/>
+          </a:effectRef>
+          <a:fontRef idx="minor">
+            <a:schemeClr val="lt1"/>
+          </a:fontRef>
+        </p:style>
+        <p:txBody>
+          <a:bodyPr rtlCol="0" anchor="ctr" lIns="54864" rIns="54864" bIns="27432" wrap="square"/>
+          <a:lstStyle/>
+          <a:p>
+            <a:pPr algn="ctr"/>
+            <a:r>
+              <a:rPr sz="1800" b="1">
+                <a:solidFill>
+                  <a:srgbClr val="1F3F2F"/>
+                </a:solidFill>
+                <a:latin typeface="Calibri"/>
+              </a:rPr>
+              <a:t>3.2–3.8 kN</a:t>
+            </a:r>
+          </a:p>
+          <a:p>
+            <a:pPr algn="ctr"/>
+            <a:r>
+              <a:rPr sz="950">
+                <a:solidFill>
+                  <a:srgbClr val="000000"/>
+                </a:solidFill>
+                <a:latin typeface="Calibri"/>
+              </a:rPr>
+              <a:t>STRONG DAY (V6 · S16)</a:t>
+            </a:r>
+          </a:p>
+        </p:txBody>
+      </p:sp>
+      <p:sp>
+        <p:nvSpPr>
+          <p:cNvPr id="8" name="Rounded Rectangle 7"/>
+          <p:cNvSpPr/>
+          <p:nvPr/>
+        </p:nvSpPr>
+        <p:spPr>
+          <a:xfrm>
+            <a:off x="8046720" y="1600200"/>
+            <a:ext cx="3794760" cy="896112"/>
+          </a:xfrm>
+          <a:prstGeom prst="roundRect">
+            <a:avLst/>
+          </a:prstGeom>
+          <a:solidFill>
+            <a:srgbClr val="E7F1F8"/>
+          </a:solidFill>
+          <a:ln>
+            <a:noFill/>
+          </a:ln>
+        </p:spPr>
+        <p:style>
+          <a:lnRef idx="1">
+            <a:schemeClr val="accent1"/>
+          </a:lnRef>
+          <a:fillRef idx="3">
+            <a:schemeClr val="accent1"/>
+          </a:fillRef>
+          <a:effectRef idx="2">
+            <a:schemeClr val="accent1"/>
+          </a:effectRef>
+          <a:fontRef idx="minor">
+            <a:schemeClr val="lt1"/>
+          </a:fontRef>
+        </p:style>
+        <p:txBody>
+          <a:bodyPr rtlCol="0" anchor="ctr" lIns="54864" rIns="54864" bIns="27432" wrap="square"/>
+          <a:lstStyle/>
+          <a:p>
+            <a:pPr algn="ctr"/>
+            <a:r>
+              <a:rPr sz="1800" b="1">
+                <a:solidFill>
+                  <a:srgbClr val="1F3F2F"/>
+                </a:solidFill>
+                <a:latin typeface="Calibri"/>
+              </a:rPr>
+              <a:t>~3.7 kN</a:t>
+            </a:r>
+          </a:p>
+          <a:p>
+            <a:pPr algn="ctr"/>
+            <a:r>
+              <a:rPr sz="950">
+                <a:solidFill>
+                  <a:srgbClr val="000000"/>
+                </a:solidFill>
+                <a:latin typeface="Calibri"/>
+              </a:rPr>
+              <a:t>100% FULL-AREA NEEDS</a:t>
+            </a:r>
+          </a:p>
+        </p:txBody>
+      </p:sp>
+      <p:sp>
+        <p:nvSpPr>
+          <p:cNvPr id="9" name="TextBox 8"/>
+          <p:cNvSpPr txBox="1"/>
+          <p:nvPr/>
+        </p:nvSpPr>
+        <p:spPr>
+          <a:xfrm>
+            <a:off x="365760" y="2788920"/>
+            <a:ext cx="11475720" cy="365760"/>
+          </a:xfrm>
+          <a:prstGeom prst="rect">
+            <a:avLst/>
+          </a:prstGeom>
+          <a:noFill/>
+        </p:spPr>
+        <p:txBody>
+          <a:bodyPr wrap="square" lIns="45720" rIns="45720" tIns="18288" bIns="18288" anchor="t">
+            <a:spAutoFit/>
+          </a:bodyPr>
+          <a:lstStyle/>
+          <a:p>
+            <a:pPr algn="l"/>
+            <a:r>
+              <a:rPr sz="1600" b="0" i="0">
+                <a:solidFill>
+                  <a:srgbClr val="707070"/>
+                </a:solidFill>
+                <a:latin typeface="Calibri"/>
+              </a:rPr>
+              <a:t>Why — torque capacity, NOT speed or software</a:t>
+            </a:r>
+          </a:p>
+        </p:txBody>
+      </p:sp>
+      <p:sp>
+        <p:nvSpPr>
+          <p:cNvPr id="10" name="TextBox 9"/>
+          <p:cNvSpPr txBox="1"/>
+          <p:nvPr/>
+        </p:nvSpPr>
+        <p:spPr>
+          <a:xfrm>
+            <a:off x="365760" y="3200400"/>
+            <a:ext cx="5669280" cy="1371600"/>
+          </a:xfrm>
+          <a:prstGeom prst="rect">
+            <a:avLst/>
+          </a:prstGeom>
+          <a:noFill/>
+        </p:spPr>
+        <p:txBody>
+          <a:bodyPr wrap="square" lIns="45720" rIns="45720" tIns="18288" bIns="18288" anchor="t">
+            <a:spAutoFit/>
+          </a:bodyPr>
+          <a:lstStyle/>
+          <a:p>
+            <a:pPr algn="l"/>
+            <a:r>
+              <a:rPr sz="1200" b="0" i="0">
+                <a:solidFill>
+                  <a:srgbClr val="000000"/>
+                </a:solidFill>
+                <a:latin typeface="Calibri"/>
+              </a:rPr>
+              <a:t>•  Driver current (Vref) set low
+•  PSU voltage sag under load</a:t>
+            </a:r>
+          </a:p>
+        </p:txBody>
+      </p:sp>
+      <p:sp>
+        <p:nvSpPr>
+          <p:cNvPr id="11" name="TextBox 10"/>
+          <p:cNvSpPr txBox="1"/>
+          <p:nvPr/>
+        </p:nvSpPr>
+        <p:spPr>
+          <a:xfrm>
+            <a:off x="6172200" y="3200400"/>
+            <a:ext cx="5669280" cy="1371600"/>
+          </a:xfrm>
+          <a:prstGeom prst="rect">
+            <a:avLst/>
+          </a:prstGeom>
+          <a:noFill/>
+        </p:spPr>
+        <p:txBody>
+          <a:bodyPr wrap="square" lIns="45720" rIns="45720" tIns="18288" bIns="18288" anchor="t">
+            <a:spAutoFit/>
+          </a:bodyPr>
+          <a:lstStyle/>
+          <a:p>
+            <a:pPr algn="l"/>
+            <a:r>
+              <a:rPr sz="1200" b="0" i="0">
+                <a:solidFill>
+                  <a:srgbClr val="000000"/>
+                </a:solidFill>
+                <a:latin typeface="Calibri"/>
+              </a:rPr>
+              <a:t>•  Driver THERMAL derating (the chip, not motor)
+•  Mechanical binding (screw / rails)</a:t>
+            </a:r>
+          </a:p>
+        </p:txBody>
+      </p:sp>
+      <p:sp>
+        <p:nvSpPr>
+          <p:cNvPr id="12" name="Rectangle 11"/>
+          <p:cNvSpPr/>
+          <p:nvPr/>
+        </p:nvSpPr>
+        <p:spPr>
+          <a:xfrm>
+            <a:off x="365760" y="4800600"/>
+            <a:ext cx="11475720" cy="914400"/>
+          </a:xfrm>
+          <a:prstGeom prst="rect">
+            <a:avLst/>
+          </a:prstGeom>
+          <a:solidFill>
+            <a:srgbClr val="FFF3CD"/>
+          </a:solidFill>
+          <a:ln>
+            <a:noFill/>
+          </a:ln>
+        </p:spPr>
+        <p:style>
+          <a:lnRef idx="1">
+            <a:schemeClr val="accent1"/>
+          </a:lnRef>
+          <a:fillRef idx="3">
+            <a:schemeClr val="accent1"/>
+          </a:fillRef>
+          <a:effectRef idx="2">
+            <a:schemeClr val="accent1"/>
+          </a:effectRef>
+          <a:fontRef idx="minor">
+            <a:schemeClr val="lt1"/>
+          </a:fontRef>
+        </p:style>
+        <p:txBody>
+          <a:bodyPr rtlCol="0" anchor="ctr" wrap="square" lIns="109728" rIns="109728"/>
+          <a:lstStyle/>
+          <a:p>
+            <a:pPr algn="ctr"/>
+            <a:r>
+              <a:rPr sz="1250" b="1">
+                <a:solidFill>
+                  <a:srgbClr val="000000"/>
+                </a:solidFill>
+                <a:latin typeface="Calibri"/>
+              </a:rPr>
+              <a:t>WORKAROUND — use 50% / smaller-cross-section specimens (fracture &lt; 2.6 kN) until the torque is restored (check Vref · cooling · PSU).</a:t>
+            </a:r>
+          </a:p>
+        </p:txBody>
+      </p:sp>
+      <p:sp>
+        <p:nvSpPr>
+          <p:cNvPr id="13" name="TextBox 12"/>
+          <p:cNvSpPr txBox="1"/>
+          <p:nvPr/>
+        </p:nvSpPr>
+        <p:spPr>
+          <a:xfrm>
+            <a:off x="548640" y="6400800"/>
+            <a:ext cx="11064240" cy="365760"/>
+          </a:xfrm>
+          <a:prstGeom prst="rect">
+            <a:avLst/>
+          </a:prstGeom>
+          <a:noFill/>
+        </p:spPr>
+        <p:txBody>
+          <a:bodyPr wrap="square" lIns="45720" rIns="45720" tIns="18288" bIns="18288" anchor="t">
+            <a:spAutoFit/>
+          </a:bodyPr>
+          <a:lstStyle/>
+          <a:p>
+            <a:pPr algn="l"/>
+            <a:r>
+              <a:rPr sz="1200" b="0" i="1">
+                <a:solidFill>
+                  <a:srgbClr val="707070"/>
+                </a:solidFill>
+                <a:latin typeface="Calibri"/>
+              </a:rPr>
+              <a:t>At the SAME 0.10 mm/s: S15 stalled 2.6 kN but S16 fractured 3.8 kN — the ceiling varies day-to-day. See TEST_FAILURES.md (S15).</a:t>
+            </a:r>
+          </a:p>
+        </p:txBody>
+      </p:sp>
+      <p:sp>
+        <p:nvSpPr>
+          <p:cNvPr id="14" name="TextBox 13"/>
           <p:cNvSpPr txBox="1"/>
           <p:nvPr/>
         </p:nvSpPr>
@@ -30150,49 +30538,14 @@
                 </a:solidFill>
                 <a:latin typeface="Calibri Light"/>
               </a:rPr>
-              <a:t>ENGINEERING vs TRUE (CAUCHY) STRESS — &amp; MEASURING THE AREA</a:t>
-            </a:r>
-          </a:p>
-        </p:txBody>
-      </p:sp>
-      <p:sp>
-        <p:nvSpPr>
-          <p:cNvPr id="5" name="TextBox 4"/>
-          <p:cNvSpPr txBox="1"/>
-          <p:nvPr/>
-        </p:nvSpPr>
-        <p:spPr>
-          <a:xfrm>
-            <a:off x="365760" y="1170432"/>
-            <a:ext cx="5577840" cy="365760"/>
-          </a:xfrm>
-          <a:prstGeom prst="rect">
-            <a:avLst/>
-          </a:prstGeom>
-          <a:noFill/>
-        </p:spPr>
-        <p:txBody>
-          <a:bodyPr wrap="square" lIns="45720" rIns="45720" tIns="18288" bIns="18288" anchor="t">
-            <a:spAutoFit/>
-          </a:bodyPr>
-          <a:lstStyle/>
-          <a:p>
-            <a:pPr algn="l"/>
-            <a:r>
-              <a:rPr sz="1600" b="0" i="0">
-                <a:solidFill>
-                  <a:srgbClr val="707070"/>
-                </a:solidFill>
-                <a:latin typeface="Calibri"/>
-              </a:rPr>
-              <a:t>Why we REPORT engineering stress</a:t>
+              <a:t>MOTOR JITTER = STALL WARNING  (a failed test)</a:t>
             </a:r>
           </a:p>
         </p:txBody>
       </p:sp>
       <p:pic>
         <p:nvPicPr>
-          <p:cNvPr id="6" name="Picture 5" descr="feat_eng_vs_true.png"/>
+          <p:cNvPr id="5" name="Picture 4" descr="feat_motor_jitter.png"/>
           <p:cNvPicPr>
             <a:picLocks noChangeAspect="1"/>
           </p:cNvPicPr>
@@ -30206,8 +30559,8 @@
         </p:blipFill>
         <p:spPr>
           <a:xfrm>
-            <a:off x="365760" y="1517904"/>
-            <a:ext cx="5623560" cy="2309892"/>
+            <a:off x="320040" y="1417320"/>
+            <a:ext cx="6766560" cy="3200400"/>
           </a:xfrm>
           <a:prstGeom prst="rect">
             <a:avLst/>
@@ -30216,14 +30569,14 @@
       </p:pic>
       <p:sp>
         <p:nvSpPr>
-          <p:cNvPr id="7" name="TextBox 6"/>
+          <p:cNvPr id="6" name="TextBox 5"/>
           <p:cNvSpPr txBox="1"/>
           <p:nvPr/>
         </p:nvSpPr>
         <p:spPr>
           <a:xfrm>
-            <a:off x="365760" y="3950208"/>
-            <a:ext cx="5623560" cy="1051560"/>
+            <a:off x="7315200" y="1170432"/>
+            <a:ext cx="4526280" cy="365760"/>
           </a:xfrm>
           <a:prstGeom prst="rect">
             <a:avLst/>
@@ -30238,28 +30591,27 @@
           <a:p>
             <a:pPr algn="l"/>
             <a:r>
-              <a:rPr sz="1100" b="0" i="0">
-                <a:solidFill>
-                  <a:srgbClr val="000000"/>
-                </a:solidFill>
-                <a:latin typeface="Calibri"/>
-              </a:rPr>
-              <a:t>σ_eng = F / A₀  (REPORTED)      σ_true = F / A  (not tracked, ~2–5% higher)
-Basis: ISO 527 · Chacón · datasheet all use ENGINEERING → apples-to-apples for our k-factors.  E &amp; σ_y ~unchanged.</a:t>
-            </a:r>
-          </a:p>
-        </p:txBody>
-      </p:sp>
-      <p:sp>
-        <p:nvSpPr>
-          <p:cNvPr id="8" name="TextBox 7"/>
+              <a:rPr sz="1600" b="0" i="0">
+                <a:solidFill>
+                  <a:srgbClr val="707070"/>
+                </a:solidFill>
+                <a:latin typeface="Calibri"/>
+              </a:rPr>
+              <a:t>What happened</a:t>
+            </a:r>
+          </a:p>
+        </p:txBody>
+      </p:sp>
+      <p:sp>
+        <p:nvSpPr>
+          <p:cNvPr id="7" name="TextBox 6"/>
           <p:cNvSpPr txBox="1"/>
           <p:nvPr/>
         </p:nvSpPr>
         <p:spPr>
           <a:xfrm>
-            <a:off x="6172200" y="1170432"/>
-            <a:ext cx="5669280" cy="365760"/>
+            <a:off x="7315200" y="1572768"/>
+            <a:ext cx="4526280" cy="1463040"/>
           </a:xfrm>
           <a:prstGeom prst="rect">
             <a:avLst/>
@@ -30274,373 +30626,28 @@
           <a:p>
             <a:pPr algn="l"/>
             <a:r>
-              <a:rPr sz="1600" b="0" i="0">
-                <a:solidFill>
-                  <a:srgbClr val="707070"/>
-                </a:solidFill>
-                <a:latin typeface="Calibri"/>
-              </a:rPr>
-              <a:t>Measuring the CURRENT area → true stress (future)</a:t>
-            </a:r>
-          </a:p>
-        </p:txBody>
-      </p:sp>
-      <p:graphicFrame>
-        <p:nvGraphicFramePr>
-          <p:cNvPr id="9" name="Table 8"/>
-          <p:cNvGraphicFramePr>
-            <a:graphicFrameLocks noGrp="1"/>
-          </p:cNvGraphicFramePr>
-          <p:nvPr/>
-        </p:nvGraphicFramePr>
-        <p:xfrm>
-          <a:off x="6172200" y="1554480"/>
-          <a:ext cx="5714998" cy="2286000"/>
-        </p:xfrm>
-        <a:graphic>
-          <a:graphicData uri="http://schemas.openxmlformats.org/drawingml/2006/table">
-            <a:tbl>
-              <a:tblPr firstRow="1" bandRow="1">
-                <a:tableStyleId>{5C22544A-7EE6-4342-B048-85BDC9FD1C3A}</a:tableStyleId>
-              </a:tblPr>
-              <a:tblGrid>
-                <a:gridCol w="1365530"/>
-                <a:gridCol w="2731061"/>
-                <a:gridCol w="1618407"/>
-              </a:tblGrid>
-              <a:tr h="457200">
-                <a:tc>
-                  <a:txBody>
-                    <a:bodyPr lIns="54864" rIns="54864" tIns="18288" bIns="18288" wrap="square" anchor="ctr"/>
-                    <a:lstStyle/>
-                    <a:p>
-                      <a:pPr algn="l"/>
-                      <a:r>
-                        <a:rPr sz="1000" b="1">
-                          <a:solidFill>
-                            <a:srgbClr val="FFFFFF"/>
-                          </a:solidFill>
-                          <a:latin typeface="Calibri"/>
-                        </a:rPr>
-                        <a:t>Method</a:t>
-                      </a:r>
-                    </a:p>
-                  </a:txBody>
-                  <a:tcPr>
-                    <a:solidFill>
-                      <a:srgbClr val="143D2F"/>
-                    </a:solidFill>
-                  </a:tcPr>
-                </a:tc>
-                <a:tc>
-                  <a:txBody>
-                    <a:bodyPr lIns="54864" rIns="54864" tIns="18288" bIns="18288" wrap="square" anchor="ctr"/>
-                    <a:lstStyle/>
-                    <a:p>
-                      <a:pPr algn="l"/>
-                      <a:r>
-                        <a:rPr sz="1000" b="1">
-                          <a:solidFill>
-                            <a:srgbClr val="FFFFFF"/>
-                          </a:solidFill>
-                          <a:latin typeface="Calibri"/>
-                        </a:rPr>
-                        <a:t>How</a:t>
-                      </a:r>
-                    </a:p>
-                  </a:txBody>
-                  <a:tcPr>
-                    <a:solidFill>
-                      <a:srgbClr val="143D2F"/>
-                    </a:solidFill>
-                  </a:tcPr>
-                </a:tc>
-                <a:tc>
-                  <a:txBody>
-                    <a:bodyPr lIns="54864" rIns="54864" tIns="18288" bIns="18288" wrap="square" anchor="ctr"/>
-                    <a:lstStyle/>
-                    <a:p>
-                      <a:pPr algn="l"/>
-                      <a:r>
-                        <a:rPr sz="1000" b="1">
-                          <a:solidFill>
-                            <a:srgbClr val="FFFFFF"/>
-                          </a:solidFill>
-                          <a:latin typeface="Calibri"/>
-                        </a:rPr>
-                        <a:t>Note</a:t>
-                      </a:r>
-                    </a:p>
-                  </a:txBody>
-                  <a:tcPr>
-                    <a:solidFill>
-                      <a:srgbClr val="143D2F"/>
-                    </a:solidFill>
-                  </a:tcPr>
-                </a:tc>
-              </a:tr>
-              <a:tr h="457200">
-                <a:tc>
-                  <a:txBody>
-                    <a:bodyPr lIns="54864" rIns="54864" tIns="18288" bIns="18288" wrap="square" anchor="ctr"/>
-                    <a:lstStyle/>
-                    <a:p>
-                      <a:pPr algn="l"/>
-                      <a:r>
-                        <a:rPr sz="950" b="0">
-                          <a:solidFill>
-                            <a:srgbClr val="000000"/>
-                          </a:solidFill>
-                          <a:latin typeface="Calibri"/>
-                        </a:rPr>
-                        <a:t>Poisson estimate</a:t>
-                      </a:r>
-                    </a:p>
-                  </a:txBody>
-                  <a:tcPr/>
-                </a:tc>
-                <a:tc>
-                  <a:txBody>
-                    <a:bodyPr lIns="54864" rIns="54864" tIns="18288" bIns="18288" wrap="square" anchor="ctr"/>
-                    <a:lstStyle/>
-                    <a:p>
-                      <a:pPr algn="l"/>
-                      <a:r>
-                        <a:rPr sz="950" b="0">
-                          <a:solidFill>
-                            <a:srgbClr val="000000"/>
-                          </a:solidFill>
-                          <a:latin typeface="Calibri"/>
-                        </a:rPr>
-                        <a:t>A = A₀(1−ν·ε)²,  ν ≈ 0.35  (no hardware)</a:t>
-                      </a:r>
-                    </a:p>
-                  </a:txBody>
-                  <a:tcPr/>
-                </a:tc>
-                <a:tc>
-                  <a:txBody>
-                    <a:bodyPr lIns="54864" rIns="54864" tIns="18288" bIns="18288" wrap="square" anchor="ctr"/>
-                    <a:lstStyle/>
-                    <a:p>
-                      <a:pPr algn="l"/>
-                      <a:r>
-                        <a:rPr sz="950" b="0">
-                          <a:solidFill>
-                            <a:srgbClr val="000000"/>
-                          </a:solidFill>
-                          <a:latin typeface="Calibri"/>
-                        </a:rPr>
-                        <a:t>cheap; ν drifts in yield</a:t>
-                      </a:r>
-                    </a:p>
-                  </a:txBody>
-                  <a:tcPr/>
-                </a:tc>
-              </a:tr>
-              <a:tr h="457200">
-                <a:tc>
-                  <a:txBody>
-                    <a:bodyPr lIns="54864" rIns="54864" tIns="18288" bIns="18288" wrap="square" anchor="ctr"/>
-                    <a:lstStyle/>
-                    <a:p>
-                      <a:pPr algn="l"/>
-                      <a:r>
-                        <a:rPr sz="950" b="1">
-                          <a:solidFill>
-                            <a:srgbClr val="000000"/>
-                          </a:solidFill>
-                          <a:latin typeface="Calibri"/>
-                        </a:rPr>
-                        <a:t>Transverse markers</a:t>
-                      </a:r>
-                    </a:p>
-                  </a:txBody>
-                  <a:tcPr>
-                    <a:solidFill>
-                      <a:srgbClr val="C8E6C9"/>
-                    </a:solidFill>
-                  </a:tcPr>
-                </a:tc>
-                <a:tc>
-                  <a:txBody>
-                    <a:bodyPr lIns="54864" rIns="54864" tIns="18288" bIns="18288" wrap="square" anchor="ctr"/>
-                    <a:lstStyle/>
-                    <a:p>
-                      <a:pPr algn="l"/>
-                      <a:r>
-                        <a:rPr sz="950" b="0">
-                          <a:solidFill>
-                            <a:srgbClr val="000000"/>
-                          </a:solidFill>
-                          <a:latin typeface="Calibri"/>
-                        </a:rPr>
-                        <a:t>+2 dots across width → ε_w;  A ≈ A₀(1+ε_w)²</a:t>
-                      </a:r>
-                    </a:p>
-                  </a:txBody>
-                  <a:tcPr>
-                    <a:solidFill>
-                      <a:srgbClr val="C8E6C9"/>
-                    </a:solidFill>
-                  </a:tcPr>
-                </a:tc>
-                <a:tc>
-                  <a:txBody>
-                    <a:bodyPr lIns="54864" rIns="54864" tIns="18288" bIns="18288" wrap="square" anchor="ctr"/>
-                    <a:lstStyle/>
-                    <a:p>
-                      <a:pPr algn="l"/>
-                      <a:r>
-                        <a:rPr sz="950" b="0">
-                          <a:solidFill>
-                            <a:srgbClr val="000000"/>
-                          </a:solidFill>
-                          <a:latin typeface="Calibri"/>
-                        </a:rPr>
-                        <a:t>reuses blob-DIC; gives Poisson</a:t>
-                      </a:r>
-                    </a:p>
-                  </a:txBody>
-                  <a:tcPr>
-                    <a:solidFill>
-                      <a:srgbClr val="C8E6C9"/>
-                    </a:solidFill>
-                  </a:tcPr>
-                </a:tc>
-              </a:tr>
-              <a:tr h="457200">
-                <a:tc>
-                  <a:txBody>
-                    <a:bodyPr lIns="54864" rIns="54864" tIns="18288" bIns="18288" wrap="square" anchor="ctr"/>
-                    <a:lstStyle/>
-                    <a:p>
-                      <a:pPr algn="l"/>
-                      <a:r>
-                        <a:rPr sz="950" b="0">
-                          <a:solidFill>
-                            <a:srgbClr val="000000"/>
-                          </a:solidFill>
-                          <a:latin typeface="Calibri"/>
-                        </a:rPr>
-                        <a:t>+ edge camera</a:t>
-                      </a:r>
-                    </a:p>
-                  </a:txBody>
-                  <a:tcPr/>
-                </a:tc>
-                <a:tc>
-                  <a:txBody>
-                    <a:bodyPr lIns="54864" rIns="54864" tIns="18288" bIns="18288" wrap="square" anchor="ctr"/>
-                    <a:lstStyle/>
-                    <a:p>
-                      <a:pPr algn="l"/>
-                      <a:r>
-                        <a:rPr sz="950" b="0">
-                          <a:solidFill>
-                            <a:srgbClr val="000000"/>
-                          </a:solidFill>
-                          <a:latin typeface="Calibri"/>
-                        </a:rPr>
-                        <a:t>2nd view → thickness strain;  A = w·t</a:t>
-                      </a:r>
-                    </a:p>
-                  </a:txBody>
-                  <a:tcPr/>
-                </a:tc>
-                <a:tc>
-                  <a:txBody>
-                    <a:bodyPr lIns="54864" rIns="54864" tIns="18288" bIns="18288" wrap="square" anchor="ctr"/>
-                    <a:lstStyle/>
-                    <a:p>
-                      <a:pPr algn="l"/>
-                      <a:r>
-                        <a:rPr sz="950" b="0">
-                          <a:solidFill>
-                            <a:srgbClr val="000000"/>
-                          </a:solidFill>
-                          <a:latin typeface="Calibri"/>
-                        </a:rPr>
-                        <a:t>rigorous; FDM is orthotropic</a:t>
-                      </a:r>
-                    </a:p>
-                  </a:txBody>
-                  <a:tcPr/>
-                </a:tc>
-              </a:tr>
-              <a:tr h="457200">
-                <a:tc>
-                  <a:txBody>
-                    <a:bodyPr lIns="54864" rIns="54864" tIns="18288" bIns="18288" wrap="square" anchor="ctr"/>
-                    <a:lstStyle/>
-                    <a:p>
-                      <a:pPr algn="l"/>
-                      <a:r>
-                        <a:rPr sz="950" b="0">
-                          <a:solidFill>
-                            <a:srgbClr val="000000"/>
-                          </a:solidFill>
-                          <a:latin typeface="Calibri"/>
-                        </a:rPr>
-                        <a:t>Full-field speckle</a:t>
-                      </a:r>
-                    </a:p>
-                  </a:txBody>
-                  <a:tcPr/>
-                </a:tc>
-                <a:tc>
-                  <a:txBody>
-                    <a:bodyPr lIns="54864" rIns="54864" tIns="18288" bIns="18288" wrap="square" anchor="ctr"/>
-                    <a:lstStyle/>
-                    <a:p>
-                      <a:pPr algn="l"/>
-                      <a:r>
-                        <a:rPr sz="950" b="0">
-                          <a:solidFill>
-                            <a:srgbClr val="000000"/>
-                          </a:solidFill>
-                          <a:latin typeface="Calibri"/>
-                        </a:rPr>
-                        <a:t>fine random speckle + subset DIC</a:t>
-                      </a:r>
-                    </a:p>
-                  </a:txBody>
-                  <a:tcPr/>
-                </a:tc>
-                <a:tc>
-                  <a:txBody>
-                    <a:bodyPr lIns="54864" rIns="54864" tIns="18288" bIns="18288" wrap="square" anchor="ctr"/>
-                    <a:lstStyle/>
-                    <a:p>
-                      <a:pPr algn="l"/>
-                      <a:r>
-                        <a:rPr sz="950" b="0">
-                          <a:solidFill>
-                            <a:srgbClr val="000000"/>
-                          </a:solidFill>
-                          <a:latin typeface="Calibri"/>
-                        </a:rPr>
-                        <a:t>strain field + necking; new pipeline</a:t>
-                      </a:r>
-                    </a:p>
-                  </a:txBody>
-                  <a:tcPr/>
-                </a:tc>
-              </a:tr>
-            </a:tbl>
-          </a:graphicData>
-        </a:graphic>
-      </p:graphicFrame>
-      <p:sp>
-        <p:nvSpPr>
-          <p:cNvPr id="10" name="TextBox 9"/>
+              <a:rPr sz="1150" b="0" i="0">
+                <a:solidFill>
+                  <a:srgbClr val="000000"/>
+                </a:solidFill>
+                <a:latin typeface="Calibri"/>
+              </a:rPr>
+              <a:t>At the force ceiling the crosshead FROZE and the whole machine SHOOK — a stalled stepper skipping steps.
+S15: had to Stop by hand.</a:t>
+            </a:r>
+          </a:p>
+        </p:txBody>
+      </p:sp>
+      <p:sp>
+        <p:nvSpPr>
+          <p:cNvPr id="8" name="TextBox 7"/>
           <p:cNvSpPr txBox="1"/>
           <p:nvPr/>
         </p:nvSpPr>
         <p:spPr>
           <a:xfrm>
-            <a:off x="6172200" y="3950208"/>
-            <a:ext cx="5715000" cy="960120"/>
+            <a:off x="7315200" y="3200400"/>
+            <a:ext cx="4526280" cy="365760"/>
           </a:xfrm>
           <a:prstGeom prst="rect">
             <a:avLst/>
@@ -30655,33 +30662,69 @@
           <a:p>
             <a:pPr algn="l"/>
             <a:r>
-              <a:rPr sz="1050" b="0" i="1">
+              <a:rPr sz="1600" b="0" i="0">
                 <a:solidFill>
                   <a:srgbClr val="707070"/>
                 </a:solidFill>
                 <a:latin typeface="Calibri"/>
               </a:rPr>
-              <a:t>Same speckle style (spray dots): just add a transverse dot pair — the current 2-marker tracker extends naturally (2 axial + 2 transverse). A finer random speckle enables full-field DIC (transverse field + necking) but needs a new analysis pipeline.</a:t>
-            </a:r>
-          </a:p>
-        </p:txBody>
-      </p:sp>
-      <p:sp>
-        <p:nvSpPr>
-          <p:cNvPr id="11" name="Rectangle 10"/>
+              <a:t>Why</a:t>
+            </a:r>
+          </a:p>
+        </p:txBody>
+      </p:sp>
+      <p:sp>
+        <p:nvSpPr>
+          <p:cNvPr id="9" name="TextBox 8"/>
+          <p:cNvSpPr txBox="1"/>
+          <p:nvPr/>
+        </p:nvSpPr>
+        <p:spPr>
+          <a:xfrm>
+            <a:off x="7315200" y="3602736"/>
+            <a:ext cx="4526280" cy="1645920"/>
+          </a:xfrm>
+          <a:prstGeom prst="rect">
+            <a:avLst/>
+          </a:prstGeom>
+          <a:noFill/>
+        </p:spPr>
+        <p:txBody>
+          <a:bodyPr wrap="square" lIns="45720" rIns="45720" tIns="18288" bIns="18288" anchor="t">
+            <a:spAutoFit/>
+          </a:bodyPr>
+          <a:lstStyle/>
+          <a:p>
+            <a:pPr algn="l"/>
+            <a:r>
+              <a:rPr sz="1150" b="0" i="0">
+                <a:solidFill>
+                  <a:srgbClr val="000000"/>
+                </a:solidFill>
+                <a:latin typeface="Calibri"/>
+              </a:rPr>
+              <a:t>•  Motor at / beyond its torque limit
+•  Strain-rate loop then oscillated, chasing a motor that can't move</a:t>
+            </a:r>
+          </a:p>
+        </p:txBody>
+      </p:sp>
+      <p:sp>
+        <p:nvSpPr>
+          <p:cNvPr id="10" name="Rectangle 9"/>
           <p:cNvSpPr/>
           <p:nvPr/>
         </p:nvSpPr>
         <p:spPr>
           <a:xfrm>
-            <a:off x="365760" y="5166360"/>
-            <a:ext cx="11521440" cy="658368"/>
+            <a:off x="365760" y="5760720"/>
+            <a:ext cx="11475720" cy="713232"/>
           </a:xfrm>
           <a:prstGeom prst="rect">
             <a:avLst/>
           </a:prstGeom>
           <a:solidFill>
-            <a:srgbClr val="E7F1F8"/>
+            <a:srgbClr val="FFCDD2"/>
           </a:solidFill>
           <a:ln>
             <a:noFill/>
@@ -30707,55 +30750,20 @@
           <a:p>
             <a:pPr algn="ctr"/>
             <a:r>
-              <a:rPr sz="1200" b="1">
+              <a:rPr sz="1250" b="1">
                 <a:solidFill>
                   <a:srgbClr val="000000"/>
                 </a:solidFill>
                 <a:latin typeface="Calibri"/>
               </a:rPr>
-              <a:t>TRANSVERSE markers = ideal, but the gauge is too NARROW → EDGE-WIDTH detection (next slide) is the practical route. Keep ENGINEERING stress as the validated basis.</a:t>
-            </a:r>
-          </a:p>
-        </p:txBody>
-      </p:sp>
-      <p:sp>
-        <p:nvSpPr>
-          <p:cNvPr id="12" name="TextBox 11"/>
-          <p:cNvSpPr txBox="1"/>
-          <p:nvPr/>
-        </p:nvSpPr>
-        <p:spPr>
-          <a:xfrm>
-            <a:off x="548640" y="6400800"/>
-            <a:ext cx="11064240" cy="365760"/>
-          </a:xfrm>
-          <a:prstGeom prst="rect">
-            <a:avLst/>
-          </a:prstGeom>
-          <a:noFill/>
-        </p:spPr>
-        <p:txBody>
-          <a:bodyPr wrap="square" lIns="45720" rIns="45720" tIns="18288" bIns="18288" anchor="t">
-            <a:spAutoFit/>
-          </a:bodyPr>
-          <a:lstStyle/>
-          <a:p>
-            <a:pPr algn="l"/>
-            <a:r>
-              <a:rPr sz="1200" b="0" i="1">
-                <a:solidFill>
-                  <a:srgbClr val="707070"/>
-                </a:solidFill>
-                <a:latin typeface="Calibri"/>
-              </a:rPr>
-              <a:t>Current V6 report &amp; plots = engineering stress (nominal 80 mm²). True/Cauchy needs the deforming area; post-necking needs full-field DIC or markers at the neck.</a:t>
-            </a:r>
-          </a:p>
-        </p:txBody>
-      </p:sp>
-      <p:sp>
-        <p:nvSpPr>
-          <p:cNvPr id="13" name="TextBox 12"/>
+              <a:t>WARNING — jitter = STALL. STOP, don't force 100% full-area. The stall guard now auto-halts (&lt; 0.05 mm in 6 s under load).</a:t>
+            </a:r>
+          </a:p>
+        </p:txBody>
+      </p:sp>
+      <p:sp>
+        <p:nvSpPr>
+          <p:cNvPr id="11" name="TextBox 10"/>
           <p:cNvSpPr txBox="1"/>
           <p:nvPr/>
         </p:nvSpPr>
@@ -30914,6 +30922,971 @@
                 </a:solidFill>
                 <a:latin typeface="Calibri Light"/>
               </a:rPr>
+              <a:t>MEASURING CAUCHY (TRUE) STRESS</a:t>
+            </a:r>
+          </a:p>
+        </p:txBody>
+      </p:sp>
+      <p:sp>
+        <p:nvSpPr>
+          <p:cNvPr id="5" name="TextBox 4"/>
+          <p:cNvSpPr txBox="1"/>
+          <p:nvPr/>
+        </p:nvSpPr>
+        <p:spPr>
+          <a:xfrm>
+            <a:off x="365760" y="2651760"/>
+            <a:ext cx="11475720" cy="1554480"/>
+          </a:xfrm>
+          <a:prstGeom prst="rect">
+            <a:avLst/>
+          </a:prstGeom>
+          <a:noFill/>
+        </p:spPr>
+        <p:txBody>
+          <a:bodyPr wrap="square" lIns="45720" rIns="45720" tIns="18288" bIns="18288" anchor="t">
+            <a:spAutoFit/>
+          </a:bodyPr>
+          <a:lstStyle/>
+          <a:p>
+            <a:pPr algn="l"/>
+            <a:r>
+              <a:rPr sz="1600" b="1" i="0">
+                <a:solidFill>
+                  <a:srgbClr val="1F3F2F"/>
+                </a:solidFill>
+                <a:latin typeface="Calibri"/>
+              </a:rPr>
+              <a:t>Getting the DEFORMING cross-section for TRUE / Cauchy stress + Poisson ratio - a separate future work-stream: edge-width tracking on a matte-black backdrop.</a:t>
+            </a:r>
+          </a:p>
+        </p:txBody>
+      </p:sp>
+      <p:sp>
+        <p:nvSpPr>
+          <p:cNvPr id="6" name="TextBox 5"/>
+          <p:cNvSpPr txBox="1"/>
+          <p:nvPr/>
+        </p:nvSpPr>
+        <p:spPr>
+          <a:xfrm>
+            <a:off x="457200" y="6446520"/>
+            <a:ext cx="640080" cy="274320"/>
+          </a:xfrm>
+          <a:prstGeom prst="rect">
+            <a:avLst/>
+          </a:prstGeom>
+          <a:noFill/>
+        </p:spPr>
+        <p:txBody>
+          <a:bodyPr wrap="square" lIns="45720" rIns="45720" tIns="18288" bIns="18288" anchor="t">
+            <a:spAutoFit/>
+          </a:bodyPr>
+          <a:lstStyle/>
+          <a:p>
+            <a:pPr algn="l"/>
+            <a:r>
+              <a:rPr sz="1000" b="0" i="0">
+                <a:solidFill>
+                  <a:srgbClr val="707070"/>
+                </a:solidFill>
+                <a:latin typeface="Calibri"/>
+              </a:rPr>
+              <a:t>183</a:t>
+            </a:r>
+          </a:p>
+        </p:txBody>
+      </p:sp>
+    </p:spTree>
+  </p:cSld>
+  <p:clrMapOvr>
+    <a:masterClrMapping/>
+  </p:clrMapOvr>
+</p:sld>
+</file>
+
+<file path=ppt/slides/slide44.xml><?xml version="1.0" encoding="utf-8"?>
+<p:sld xmlns:a="http://schemas.openxmlformats.org/drawingml/2006/main" xmlns:p="http://schemas.openxmlformats.org/presentationml/2006/main" xmlns:r="http://schemas.openxmlformats.org/officeDocument/2006/relationships">
+  <p:cSld>
+    <p:spTree>
+      <p:nvGrpSpPr>
+        <p:cNvPr id="1" name=""/>
+        <p:cNvGrpSpPr/>
+        <p:nvPr/>
+      </p:nvGrpSpPr>
+      <p:grpSpPr/>
+      <p:sp>
+        <p:nvSpPr>
+          <p:cNvPr id="2" name="TextBox 1"/>
+          <p:cNvSpPr txBox="1"/>
+          <p:nvPr/>
+        </p:nvSpPr>
+        <p:spPr>
+          <a:xfrm>
+            <a:off x="11155680" y="274320"/>
+            <a:ext cx="914400" cy="274320"/>
+          </a:xfrm>
+          <a:prstGeom prst="rect">
+            <a:avLst/>
+          </a:prstGeom>
+          <a:noFill/>
+        </p:spPr>
+        <p:txBody>
+          <a:bodyPr wrap="square" lIns="45720" rIns="45720" tIns="18288" bIns="18288" anchor="t">
+            <a:spAutoFit/>
+          </a:bodyPr>
+          <a:lstStyle/>
+          <a:p>
+            <a:pPr algn="r"/>
+            <a:r>
+              <a:rPr sz="800" b="1" i="0">
+                <a:solidFill>
+                  <a:srgbClr val="707070"/>
+                </a:solidFill>
+                <a:latin typeface="Calibri"/>
+              </a:rPr>
+              <a:t>JÖNKÖPING UNIVERSITY</a:t>
+            </a:r>
+          </a:p>
+        </p:txBody>
+      </p:sp>
+      <p:sp>
+        <p:nvSpPr>
+          <p:cNvPr id="3" name="Rectangle 2"/>
+          <p:cNvSpPr/>
+          <p:nvPr/>
+        </p:nvSpPr>
+        <p:spPr>
+          <a:xfrm>
+            <a:off x="457200" y="411480"/>
+            <a:ext cx="457200" cy="73152"/>
+          </a:xfrm>
+          <a:prstGeom prst="rect">
+            <a:avLst/>
+          </a:prstGeom>
+          <a:solidFill>
+            <a:srgbClr val="A9D6EF"/>
+          </a:solidFill>
+          <a:ln>
+            <a:noFill/>
+          </a:ln>
+        </p:spPr>
+        <p:style>
+          <a:lnRef idx="1">
+            <a:schemeClr val="accent1"/>
+          </a:lnRef>
+          <a:fillRef idx="3">
+            <a:schemeClr val="accent1"/>
+          </a:fillRef>
+          <a:effectRef idx="2">
+            <a:schemeClr val="accent1"/>
+          </a:effectRef>
+          <a:fontRef idx="minor">
+            <a:schemeClr val="lt1"/>
+          </a:fontRef>
+        </p:style>
+        <p:txBody>
+          <a:bodyPr rtlCol="0" anchor="ctr"/>
+          <a:lstStyle/>
+          <a:p>
+            <a:pPr algn="ctr"/>
+          </a:p>
+        </p:txBody>
+      </p:sp>
+      <p:sp>
+        <p:nvSpPr>
+          <p:cNvPr id="4" name="TextBox 3"/>
+          <p:cNvSpPr txBox="1"/>
+          <p:nvPr/>
+        </p:nvSpPr>
+        <p:spPr>
+          <a:xfrm>
+            <a:off x="457200" y="502920"/>
+            <a:ext cx="11430000" cy="822960"/>
+          </a:xfrm>
+          <a:prstGeom prst="rect">
+            <a:avLst/>
+          </a:prstGeom>
+          <a:noFill/>
+        </p:spPr>
+        <p:txBody>
+          <a:bodyPr wrap="square" lIns="45720" rIns="45720" tIns="18288" bIns="18288" anchor="t">
+            <a:spAutoFit/>
+          </a:bodyPr>
+          <a:lstStyle/>
+          <a:p>
+            <a:pPr algn="l"/>
+            <a:r>
+              <a:rPr sz="3000" b="0" i="0">
+                <a:solidFill>
+                  <a:srgbClr val="000000"/>
+                </a:solidFill>
+                <a:latin typeface="Calibri Light"/>
+              </a:rPr>
+              <a:t>ENGINEERING vs TRUE (CAUCHY) STRESS — &amp; MEASURING THE AREA</a:t>
+            </a:r>
+          </a:p>
+        </p:txBody>
+      </p:sp>
+      <p:sp>
+        <p:nvSpPr>
+          <p:cNvPr id="5" name="TextBox 4"/>
+          <p:cNvSpPr txBox="1"/>
+          <p:nvPr/>
+        </p:nvSpPr>
+        <p:spPr>
+          <a:xfrm>
+            <a:off x="365760" y="1170432"/>
+            <a:ext cx="5577840" cy="365760"/>
+          </a:xfrm>
+          <a:prstGeom prst="rect">
+            <a:avLst/>
+          </a:prstGeom>
+          <a:noFill/>
+        </p:spPr>
+        <p:txBody>
+          <a:bodyPr wrap="square" lIns="45720" rIns="45720" tIns="18288" bIns="18288" anchor="t">
+            <a:spAutoFit/>
+          </a:bodyPr>
+          <a:lstStyle/>
+          <a:p>
+            <a:pPr algn="l"/>
+            <a:r>
+              <a:rPr sz="1600" b="0" i="0">
+                <a:solidFill>
+                  <a:srgbClr val="707070"/>
+                </a:solidFill>
+                <a:latin typeface="Calibri"/>
+              </a:rPr>
+              <a:t>Why we REPORT engineering stress</a:t>
+            </a:r>
+          </a:p>
+        </p:txBody>
+      </p:sp>
+      <p:pic>
+        <p:nvPicPr>
+          <p:cNvPr id="6" name="Picture 5" descr="feat_eng_vs_true.png"/>
+          <p:cNvPicPr>
+            <a:picLocks noChangeAspect="1"/>
+          </p:cNvPicPr>
+          <p:nvPr/>
+        </p:nvPicPr>
+        <p:blipFill>
+          <a:blip r:embed="rId2"/>
+          <a:stretch>
+            <a:fillRect/>
+          </a:stretch>
+        </p:blipFill>
+        <p:spPr>
+          <a:xfrm>
+            <a:off x="365760" y="1517904"/>
+            <a:ext cx="5623560" cy="2309892"/>
+          </a:xfrm>
+          <a:prstGeom prst="rect">
+            <a:avLst/>
+          </a:prstGeom>
+        </p:spPr>
+      </p:pic>
+      <p:sp>
+        <p:nvSpPr>
+          <p:cNvPr id="7" name="TextBox 6"/>
+          <p:cNvSpPr txBox="1"/>
+          <p:nvPr/>
+        </p:nvSpPr>
+        <p:spPr>
+          <a:xfrm>
+            <a:off x="365760" y="3950208"/>
+            <a:ext cx="5623560" cy="1051560"/>
+          </a:xfrm>
+          <a:prstGeom prst="rect">
+            <a:avLst/>
+          </a:prstGeom>
+          <a:noFill/>
+        </p:spPr>
+        <p:txBody>
+          <a:bodyPr wrap="square" lIns="45720" rIns="45720" tIns="18288" bIns="18288" anchor="t">
+            <a:spAutoFit/>
+          </a:bodyPr>
+          <a:lstStyle/>
+          <a:p>
+            <a:pPr algn="l"/>
+            <a:r>
+              <a:rPr sz="1100" b="0" i="0">
+                <a:solidFill>
+                  <a:srgbClr val="000000"/>
+                </a:solidFill>
+                <a:latin typeface="Calibri"/>
+              </a:rPr>
+              <a:t>σ_eng = F / A₀  (REPORTED)      σ_true = F / A  (not tracked, ~2–5% higher)
+Basis: ISO 527 · Chacón · datasheet all use ENGINEERING → apples-to-apples for our k-factors.  E &amp; σ_y ~unchanged.</a:t>
+            </a:r>
+          </a:p>
+        </p:txBody>
+      </p:sp>
+      <p:sp>
+        <p:nvSpPr>
+          <p:cNvPr id="8" name="TextBox 7"/>
+          <p:cNvSpPr txBox="1"/>
+          <p:nvPr/>
+        </p:nvSpPr>
+        <p:spPr>
+          <a:xfrm>
+            <a:off x="6172200" y="1170432"/>
+            <a:ext cx="5669280" cy="365760"/>
+          </a:xfrm>
+          <a:prstGeom prst="rect">
+            <a:avLst/>
+          </a:prstGeom>
+          <a:noFill/>
+        </p:spPr>
+        <p:txBody>
+          <a:bodyPr wrap="square" lIns="45720" rIns="45720" tIns="18288" bIns="18288" anchor="t">
+            <a:spAutoFit/>
+          </a:bodyPr>
+          <a:lstStyle/>
+          <a:p>
+            <a:pPr algn="l"/>
+            <a:r>
+              <a:rPr sz="1600" b="0" i="0">
+                <a:solidFill>
+                  <a:srgbClr val="707070"/>
+                </a:solidFill>
+                <a:latin typeface="Calibri"/>
+              </a:rPr>
+              <a:t>Measuring the CURRENT area → true stress (future)</a:t>
+            </a:r>
+          </a:p>
+        </p:txBody>
+      </p:sp>
+      <p:graphicFrame>
+        <p:nvGraphicFramePr>
+          <p:cNvPr id="9" name="Table 8"/>
+          <p:cNvGraphicFramePr>
+            <a:graphicFrameLocks noGrp="1"/>
+          </p:cNvGraphicFramePr>
+          <p:nvPr/>
+        </p:nvGraphicFramePr>
+        <p:xfrm>
+          <a:off x="6172200" y="1554480"/>
+          <a:ext cx="5714998" cy="2286000"/>
+        </p:xfrm>
+        <a:graphic>
+          <a:graphicData uri="http://schemas.openxmlformats.org/drawingml/2006/table">
+            <a:tbl>
+              <a:tblPr firstRow="1" bandRow="1">
+                <a:tableStyleId>{5C22544A-7EE6-4342-B048-85BDC9FD1C3A}</a:tableStyleId>
+              </a:tblPr>
+              <a:tblGrid>
+                <a:gridCol w="1365530"/>
+                <a:gridCol w="2731061"/>
+                <a:gridCol w="1618407"/>
+              </a:tblGrid>
+              <a:tr h="457200">
+                <a:tc>
+                  <a:txBody>
+                    <a:bodyPr lIns="54864" rIns="54864" tIns="18288" bIns="18288" wrap="square" anchor="ctr"/>
+                    <a:lstStyle/>
+                    <a:p>
+                      <a:pPr algn="l"/>
+                      <a:r>
+                        <a:rPr sz="1000" b="1">
+                          <a:solidFill>
+                            <a:srgbClr val="FFFFFF"/>
+                          </a:solidFill>
+                          <a:latin typeface="Calibri"/>
+                        </a:rPr>
+                        <a:t>Method</a:t>
+                      </a:r>
+                    </a:p>
+                  </a:txBody>
+                  <a:tcPr>
+                    <a:solidFill>
+                      <a:srgbClr val="143D2F"/>
+                    </a:solidFill>
+                  </a:tcPr>
+                </a:tc>
+                <a:tc>
+                  <a:txBody>
+                    <a:bodyPr lIns="54864" rIns="54864" tIns="18288" bIns="18288" wrap="square" anchor="ctr"/>
+                    <a:lstStyle/>
+                    <a:p>
+                      <a:pPr algn="l"/>
+                      <a:r>
+                        <a:rPr sz="1000" b="1">
+                          <a:solidFill>
+                            <a:srgbClr val="FFFFFF"/>
+                          </a:solidFill>
+                          <a:latin typeface="Calibri"/>
+                        </a:rPr>
+                        <a:t>How</a:t>
+                      </a:r>
+                    </a:p>
+                  </a:txBody>
+                  <a:tcPr>
+                    <a:solidFill>
+                      <a:srgbClr val="143D2F"/>
+                    </a:solidFill>
+                  </a:tcPr>
+                </a:tc>
+                <a:tc>
+                  <a:txBody>
+                    <a:bodyPr lIns="54864" rIns="54864" tIns="18288" bIns="18288" wrap="square" anchor="ctr"/>
+                    <a:lstStyle/>
+                    <a:p>
+                      <a:pPr algn="l"/>
+                      <a:r>
+                        <a:rPr sz="1000" b="1">
+                          <a:solidFill>
+                            <a:srgbClr val="FFFFFF"/>
+                          </a:solidFill>
+                          <a:latin typeface="Calibri"/>
+                        </a:rPr>
+                        <a:t>Note</a:t>
+                      </a:r>
+                    </a:p>
+                  </a:txBody>
+                  <a:tcPr>
+                    <a:solidFill>
+                      <a:srgbClr val="143D2F"/>
+                    </a:solidFill>
+                  </a:tcPr>
+                </a:tc>
+              </a:tr>
+              <a:tr h="457200">
+                <a:tc>
+                  <a:txBody>
+                    <a:bodyPr lIns="54864" rIns="54864" tIns="18288" bIns="18288" wrap="square" anchor="ctr"/>
+                    <a:lstStyle/>
+                    <a:p>
+                      <a:pPr algn="l"/>
+                      <a:r>
+                        <a:rPr sz="950" b="0">
+                          <a:solidFill>
+                            <a:srgbClr val="000000"/>
+                          </a:solidFill>
+                          <a:latin typeface="Calibri"/>
+                        </a:rPr>
+                        <a:t>Poisson estimate</a:t>
+                      </a:r>
+                    </a:p>
+                  </a:txBody>
+                  <a:tcPr/>
+                </a:tc>
+                <a:tc>
+                  <a:txBody>
+                    <a:bodyPr lIns="54864" rIns="54864" tIns="18288" bIns="18288" wrap="square" anchor="ctr"/>
+                    <a:lstStyle/>
+                    <a:p>
+                      <a:pPr algn="l"/>
+                      <a:r>
+                        <a:rPr sz="950" b="0">
+                          <a:solidFill>
+                            <a:srgbClr val="000000"/>
+                          </a:solidFill>
+                          <a:latin typeface="Calibri"/>
+                        </a:rPr>
+                        <a:t>A = A₀(1−ν·ε)²,  ν ≈ 0.35  (no hardware)</a:t>
+                      </a:r>
+                    </a:p>
+                  </a:txBody>
+                  <a:tcPr/>
+                </a:tc>
+                <a:tc>
+                  <a:txBody>
+                    <a:bodyPr lIns="54864" rIns="54864" tIns="18288" bIns="18288" wrap="square" anchor="ctr"/>
+                    <a:lstStyle/>
+                    <a:p>
+                      <a:pPr algn="l"/>
+                      <a:r>
+                        <a:rPr sz="950" b="0">
+                          <a:solidFill>
+                            <a:srgbClr val="000000"/>
+                          </a:solidFill>
+                          <a:latin typeface="Calibri"/>
+                        </a:rPr>
+                        <a:t>cheap; ν drifts in yield</a:t>
+                      </a:r>
+                    </a:p>
+                  </a:txBody>
+                  <a:tcPr/>
+                </a:tc>
+              </a:tr>
+              <a:tr h="457200">
+                <a:tc>
+                  <a:txBody>
+                    <a:bodyPr lIns="54864" rIns="54864" tIns="18288" bIns="18288" wrap="square" anchor="ctr"/>
+                    <a:lstStyle/>
+                    <a:p>
+                      <a:pPr algn="l"/>
+                      <a:r>
+                        <a:rPr sz="950" b="1">
+                          <a:solidFill>
+                            <a:srgbClr val="000000"/>
+                          </a:solidFill>
+                          <a:latin typeface="Calibri"/>
+                        </a:rPr>
+                        <a:t>Transverse markers</a:t>
+                      </a:r>
+                    </a:p>
+                  </a:txBody>
+                  <a:tcPr>
+                    <a:solidFill>
+                      <a:srgbClr val="C8E6C9"/>
+                    </a:solidFill>
+                  </a:tcPr>
+                </a:tc>
+                <a:tc>
+                  <a:txBody>
+                    <a:bodyPr lIns="54864" rIns="54864" tIns="18288" bIns="18288" wrap="square" anchor="ctr"/>
+                    <a:lstStyle/>
+                    <a:p>
+                      <a:pPr algn="l"/>
+                      <a:r>
+                        <a:rPr sz="950" b="0">
+                          <a:solidFill>
+                            <a:srgbClr val="000000"/>
+                          </a:solidFill>
+                          <a:latin typeface="Calibri"/>
+                        </a:rPr>
+                        <a:t>+2 dots across width → ε_w;  A ≈ A₀(1+ε_w)²</a:t>
+                      </a:r>
+                    </a:p>
+                  </a:txBody>
+                  <a:tcPr>
+                    <a:solidFill>
+                      <a:srgbClr val="C8E6C9"/>
+                    </a:solidFill>
+                  </a:tcPr>
+                </a:tc>
+                <a:tc>
+                  <a:txBody>
+                    <a:bodyPr lIns="54864" rIns="54864" tIns="18288" bIns="18288" wrap="square" anchor="ctr"/>
+                    <a:lstStyle/>
+                    <a:p>
+                      <a:pPr algn="l"/>
+                      <a:r>
+                        <a:rPr sz="950" b="0">
+                          <a:solidFill>
+                            <a:srgbClr val="000000"/>
+                          </a:solidFill>
+                          <a:latin typeface="Calibri"/>
+                        </a:rPr>
+                        <a:t>reuses blob-DIC; gives Poisson</a:t>
+                      </a:r>
+                    </a:p>
+                  </a:txBody>
+                  <a:tcPr>
+                    <a:solidFill>
+                      <a:srgbClr val="C8E6C9"/>
+                    </a:solidFill>
+                  </a:tcPr>
+                </a:tc>
+              </a:tr>
+              <a:tr h="457200">
+                <a:tc>
+                  <a:txBody>
+                    <a:bodyPr lIns="54864" rIns="54864" tIns="18288" bIns="18288" wrap="square" anchor="ctr"/>
+                    <a:lstStyle/>
+                    <a:p>
+                      <a:pPr algn="l"/>
+                      <a:r>
+                        <a:rPr sz="950" b="0">
+                          <a:solidFill>
+                            <a:srgbClr val="000000"/>
+                          </a:solidFill>
+                          <a:latin typeface="Calibri"/>
+                        </a:rPr>
+                        <a:t>+ edge camera</a:t>
+                      </a:r>
+                    </a:p>
+                  </a:txBody>
+                  <a:tcPr/>
+                </a:tc>
+                <a:tc>
+                  <a:txBody>
+                    <a:bodyPr lIns="54864" rIns="54864" tIns="18288" bIns="18288" wrap="square" anchor="ctr"/>
+                    <a:lstStyle/>
+                    <a:p>
+                      <a:pPr algn="l"/>
+                      <a:r>
+                        <a:rPr sz="950" b="0">
+                          <a:solidFill>
+                            <a:srgbClr val="000000"/>
+                          </a:solidFill>
+                          <a:latin typeface="Calibri"/>
+                        </a:rPr>
+                        <a:t>2nd view → thickness strain;  A = w·t</a:t>
+                      </a:r>
+                    </a:p>
+                  </a:txBody>
+                  <a:tcPr/>
+                </a:tc>
+                <a:tc>
+                  <a:txBody>
+                    <a:bodyPr lIns="54864" rIns="54864" tIns="18288" bIns="18288" wrap="square" anchor="ctr"/>
+                    <a:lstStyle/>
+                    <a:p>
+                      <a:pPr algn="l"/>
+                      <a:r>
+                        <a:rPr sz="950" b="0">
+                          <a:solidFill>
+                            <a:srgbClr val="000000"/>
+                          </a:solidFill>
+                          <a:latin typeface="Calibri"/>
+                        </a:rPr>
+                        <a:t>rigorous; FDM is orthotropic</a:t>
+                      </a:r>
+                    </a:p>
+                  </a:txBody>
+                  <a:tcPr/>
+                </a:tc>
+              </a:tr>
+              <a:tr h="457200">
+                <a:tc>
+                  <a:txBody>
+                    <a:bodyPr lIns="54864" rIns="54864" tIns="18288" bIns="18288" wrap="square" anchor="ctr"/>
+                    <a:lstStyle/>
+                    <a:p>
+                      <a:pPr algn="l"/>
+                      <a:r>
+                        <a:rPr sz="950" b="0">
+                          <a:solidFill>
+                            <a:srgbClr val="000000"/>
+                          </a:solidFill>
+                          <a:latin typeface="Calibri"/>
+                        </a:rPr>
+                        <a:t>Full-field speckle</a:t>
+                      </a:r>
+                    </a:p>
+                  </a:txBody>
+                  <a:tcPr/>
+                </a:tc>
+                <a:tc>
+                  <a:txBody>
+                    <a:bodyPr lIns="54864" rIns="54864" tIns="18288" bIns="18288" wrap="square" anchor="ctr"/>
+                    <a:lstStyle/>
+                    <a:p>
+                      <a:pPr algn="l"/>
+                      <a:r>
+                        <a:rPr sz="950" b="0">
+                          <a:solidFill>
+                            <a:srgbClr val="000000"/>
+                          </a:solidFill>
+                          <a:latin typeface="Calibri"/>
+                        </a:rPr>
+                        <a:t>fine random speckle + subset DIC</a:t>
+                      </a:r>
+                    </a:p>
+                  </a:txBody>
+                  <a:tcPr/>
+                </a:tc>
+                <a:tc>
+                  <a:txBody>
+                    <a:bodyPr lIns="54864" rIns="54864" tIns="18288" bIns="18288" wrap="square" anchor="ctr"/>
+                    <a:lstStyle/>
+                    <a:p>
+                      <a:pPr algn="l"/>
+                      <a:r>
+                        <a:rPr sz="950" b="0">
+                          <a:solidFill>
+                            <a:srgbClr val="000000"/>
+                          </a:solidFill>
+                          <a:latin typeface="Calibri"/>
+                        </a:rPr>
+                        <a:t>strain field + necking; new pipeline</a:t>
+                      </a:r>
+                    </a:p>
+                  </a:txBody>
+                  <a:tcPr/>
+                </a:tc>
+              </a:tr>
+            </a:tbl>
+          </a:graphicData>
+        </a:graphic>
+      </p:graphicFrame>
+      <p:sp>
+        <p:nvSpPr>
+          <p:cNvPr id="10" name="TextBox 9"/>
+          <p:cNvSpPr txBox="1"/>
+          <p:nvPr/>
+        </p:nvSpPr>
+        <p:spPr>
+          <a:xfrm>
+            <a:off x="6172200" y="3950208"/>
+            <a:ext cx="5715000" cy="960120"/>
+          </a:xfrm>
+          <a:prstGeom prst="rect">
+            <a:avLst/>
+          </a:prstGeom>
+          <a:noFill/>
+        </p:spPr>
+        <p:txBody>
+          <a:bodyPr wrap="square" lIns="45720" rIns="45720" tIns="18288" bIns="18288" anchor="t">
+            <a:spAutoFit/>
+          </a:bodyPr>
+          <a:lstStyle/>
+          <a:p>
+            <a:pPr algn="l"/>
+            <a:r>
+              <a:rPr sz="1050" b="0" i="1">
+                <a:solidFill>
+                  <a:srgbClr val="707070"/>
+                </a:solidFill>
+                <a:latin typeface="Calibri"/>
+              </a:rPr>
+              <a:t>Same speckle style (spray dots): just add a transverse dot pair — the current 2-marker tracker extends naturally (2 axial + 2 transverse). A finer random speckle enables full-field DIC (transverse field + necking) but needs a new analysis pipeline.</a:t>
+            </a:r>
+          </a:p>
+        </p:txBody>
+      </p:sp>
+      <p:sp>
+        <p:nvSpPr>
+          <p:cNvPr id="11" name="Rectangle 10"/>
+          <p:cNvSpPr/>
+          <p:nvPr/>
+        </p:nvSpPr>
+        <p:spPr>
+          <a:xfrm>
+            <a:off x="365760" y="5166360"/>
+            <a:ext cx="11521440" cy="658368"/>
+          </a:xfrm>
+          <a:prstGeom prst="rect">
+            <a:avLst/>
+          </a:prstGeom>
+          <a:solidFill>
+            <a:srgbClr val="E7F1F8"/>
+          </a:solidFill>
+          <a:ln>
+            <a:noFill/>
+          </a:ln>
+        </p:spPr>
+        <p:style>
+          <a:lnRef idx="1">
+            <a:schemeClr val="accent1"/>
+          </a:lnRef>
+          <a:fillRef idx="3">
+            <a:schemeClr val="accent1"/>
+          </a:fillRef>
+          <a:effectRef idx="2">
+            <a:schemeClr val="accent1"/>
+          </a:effectRef>
+          <a:fontRef idx="minor">
+            <a:schemeClr val="lt1"/>
+          </a:fontRef>
+        </p:style>
+        <p:txBody>
+          <a:bodyPr rtlCol="0" anchor="ctr" wrap="square" lIns="109728" rIns="109728"/>
+          <a:lstStyle/>
+          <a:p>
+            <a:pPr algn="ctr"/>
+            <a:r>
+              <a:rPr sz="1200" b="1">
+                <a:solidFill>
+                  <a:srgbClr val="000000"/>
+                </a:solidFill>
+                <a:latin typeface="Calibri"/>
+              </a:rPr>
+              <a:t>TRANSVERSE markers = ideal, but the gauge is too NARROW → EDGE-WIDTH detection (next slide) is the practical route. Keep ENGINEERING stress as the validated basis.</a:t>
+            </a:r>
+          </a:p>
+        </p:txBody>
+      </p:sp>
+      <p:sp>
+        <p:nvSpPr>
+          <p:cNvPr id="12" name="TextBox 11"/>
+          <p:cNvSpPr txBox="1"/>
+          <p:nvPr/>
+        </p:nvSpPr>
+        <p:spPr>
+          <a:xfrm>
+            <a:off x="548640" y="6400800"/>
+            <a:ext cx="11064240" cy="365760"/>
+          </a:xfrm>
+          <a:prstGeom prst="rect">
+            <a:avLst/>
+          </a:prstGeom>
+          <a:noFill/>
+        </p:spPr>
+        <p:txBody>
+          <a:bodyPr wrap="square" lIns="45720" rIns="45720" tIns="18288" bIns="18288" anchor="t">
+            <a:spAutoFit/>
+          </a:bodyPr>
+          <a:lstStyle/>
+          <a:p>
+            <a:pPr algn="l"/>
+            <a:r>
+              <a:rPr sz="1200" b="0" i="1">
+                <a:solidFill>
+                  <a:srgbClr val="707070"/>
+                </a:solidFill>
+                <a:latin typeface="Calibri"/>
+              </a:rPr>
+              <a:t>Current V6 report &amp; plots = engineering stress (nominal 80 mm²). True/Cauchy needs the deforming area; post-necking needs full-field DIC or markers at the neck.</a:t>
+            </a:r>
+          </a:p>
+        </p:txBody>
+      </p:sp>
+      <p:sp>
+        <p:nvSpPr>
+          <p:cNvPr id="13" name="TextBox 12"/>
+          <p:cNvSpPr txBox="1"/>
+          <p:nvPr/>
+        </p:nvSpPr>
+        <p:spPr>
+          <a:xfrm>
+            <a:off x="457200" y="6446520"/>
+            <a:ext cx="640080" cy="274320"/>
+          </a:xfrm>
+          <a:prstGeom prst="rect">
+            <a:avLst/>
+          </a:prstGeom>
+          <a:noFill/>
+        </p:spPr>
+        <p:txBody>
+          <a:bodyPr wrap="square" lIns="45720" rIns="45720" tIns="18288" bIns="18288" anchor="t">
+            <a:spAutoFit/>
+          </a:bodyPr>
+          <a:lstStyle/>
+          <a:p>
+            <a:pPr algn="l"/>
+            <a:r>
+              <a:rPr sz="1000" b="0" i="0">
+                <a:solidFill>
+                  <a:srgbClr val="707070"/>
+                </a:solidFill>
+                <a:latin typeface="Calibri"/>
+              </a:rPr>
+              <a:t>184</a:t>
+            </a:r>
+          </a:p>
+        </p:txBody>
+      </p:sp>
+    </p:spTree>
+  </p:cSld>
+  <p:clrMapOvr>
+    <a:masterClrMapping/>
+  </p:clrMapOvr>
+</p:sld>
+</file>
+
+<file path=ppt/slides/slide45.xml><?xml version="1.0" encoding="utf-8"?>
+<p:sld xmlns:a="http://schemas.openxmlformats.org/drawingml/2006/main" xmlns:p="http://schemas.openxmlformats.org/presentationml/2006/main" xmlns:r="http://schemas.openxmlformats.org/officeDocument/2006/relationships">
+  <p:cSld>
+    <p:spTree>
+      <p:nvGrpSpPr>
+        <p:cNvPr id="1" name=""/>
+        <p:cNvGrpSpPr/>
+        <p:nvPr/>
+      </p:nvGrpSpPr>
+      <p:grpSpPr/>
+      <p:sp>
+        <p:nvSpPr>
+          <p:cNvPr id="2" name="TextBox 1"/>
+          <p:cNvSpPr txBox="1"/>
+          <p:nvPr/>
+        </p:nvSpPr>
+        <p:spPr>
+          <a:xfrm>
+            <a:off x="11155680" y="274320"/>
+            <a:ext cx="914400" cy="274320"/>
+          </a:xfrm>
+          <a:prstGeom prst="rect">
+            <a:avLst/>
+          </a:prstGeom>
+          <a:noFill/>
+        </p:spPr>
+        <p:txBody>
+          <a:bodyPr wrap="square" lIns="45720" rIns="45720" tIns="18288" bIns="18288" anchor="t">
+            <a:spAutoFit/>
+          </a:bodyPr>
+          <a:lstStyle/>
+          <a:p>
+            <a:pPr algn="r"/>
+            <a:r>
+              <a:rPr sz="800" b="1" i="0">
+                <a:solidFill>
+                  <a:srgbClr val="707070"/>
+                </a:solidFill>
+                <a:latin typeface="Calibri"/>
+              </a:rPr>
+              <a:t>JÖNKÖPING UNIVERSITY</a:t>
+            </a:r>
+          </a:p>
+        </p:txBody>
+      </p:sp>
+      <p:sp>
+        <p:nvSpPr>
+          <p:cNvPr id="3" name="Rectangle 2"/>
+          <p:cNvSpPr/>
+          <p:nvPr/>
+        </p:nvSpPr>
+        <p:spPr>
+          <a:xfrm>
+            <a:off x="457200" y="411480"/>
+            <a:ext cx="457200" cy="73152"/>
+          </a:xfrm>
+          <a:prstGeom prst="rect">
+            <a:avLst/>
+          </a:prstGeom>
+          <a:solidFill>
+            <a:srgbClr val="A9D6EF"/>
+          </a:solidFill>
+          <a:ln>
+            <a:noFill/>
+          </a:ln>
+        </p:spPr>
+        <p:style>
+          <a:lnRef idx="1">
+            <a:schemeClr val="accent1"/>
+          </a:lnRef>
+          <a:fillRef idx="3">
+            <a:schemeClr val="accent1"/>
+          </a:fillRef>
+          <a:effectRef idx="2">
+            <a:schemeClr val="accent1"/>
+          </a:effectRef>
+          <a:fontRef idx="minor">
+            <a:schemeClr val="lt1"/>
+          </a:fontRef>
+        </p:style>
+        <p:txBody>
+          <a:bodyPr rtlCol="0" anchor="ctr"/>
+          <a:lstStyle/>
+          <a:p>
+            <a:pPr algn="ctr"/>
+          </a:p>
+        </p:txBody>
+      </p:sp>
+      <p:sp>
+        <p:nvSpPr>
+          <p:cNvPr id="4" name="TextBox 3"/>
+          <p:cNvSpPr txBox="1"/>
+          <p:nvPr/>
+        </p:nvSpPr>
+        <p:spPr>
+          <a:xfrm>
+            <a:off x="457200" y="502920"/>
+            <a:ext cx="11430000" cy="822960"/>
+          </a:xfrm>
+          <a:prstGeom prst="rect">
+            <a:avLst/>
+          </a:prstGeom>
+          <a:noFill/>
+        </p:spPr>
+        <p:txBody>
+          <a:bodyPr wrap="square" lIns="45720" rIns="45720" tIns="18288" bIns="18288" anchor="t">
+            <a:spAutoFit/>
+          </a:bodyPr>
+          <a:lstStyle/>
+          <a:p>
+            <a:pPr algn="l"/>
+            <a:r>
+              <a:rPr sz="3000" b="0" i="0">
+                <a:solidFill>
+                  <a:srgbClr val="000000"/>
+                </a:solidFill>
+                <a:latin typeface="Calibri Light"/>
+              </a:rPr>
               <a:t>MEASURING POISSON'S RATIO &amp; TRUE STRESS — WITHOUT TRANSVERSE DOTS</a:t>
             </a:r>
           </a:p>
@@ -31493,7 +32466,7 @@
                 </a:solidFill>
                 <a:latin typeface="Calibri"/>
               </a:rPr>
-              <a:t>183</a:t>
+              <a:t>185</a:t>
             </a:r>
           </a:p>
         </p:txBody>

</xml_diff>